<commit_message>
docs: include official dbdiagram export in presentation package
</commit_message>
<xml_diff>
--- a/docs/thiet-ke-csdl-va-phan-tich-nghiep-vu.pptx
+++ b/docs/thiet-ke-csdl-va-phan-tich-nghiep-vu.pptx
@@ -26,6 +26,7 @@
     <p:sldId id="274" r:id="rId25"/>
     <p:sldId id="275" r:id="rId26"/>
     <p:sldId id="276" r:id="rId27"/>
+    <p:sldId id="277" r:id="rId28"/>
   </p:sldIdLst>
   <p:sldSz cx="12191999" cy="6858000" type="screen4x3"/>
   <p:notesSz cx="6858000" cy="9144000"/>
@@ -20175,6 +20176,338 @@
 </p:sld>
 </file>
 
+<file path=ppt/slides/slide22.xml><?xml version="1.0" encoding="utf-8"?>
+<p:sld xmlns:a="http://schemas.openxmlformats.org/drawingml/2006/main" xmlns:p="http://schemas.openxmlformats.org/presentationml/2006/main" xmlns:r="http://schemas.openxmlformats.org/officeDocument/2006/relationships">
+  <p:cSld>
+    <p:bg>
+      <p:bgPr>
+        <a:solidFill>
+          <a:srgbClr val="FFFFFF"/>
+        </a:solidFill>
+        <a:effectLst/>
+      </p:bgPr>
+    </p:bg>
+    <p:spTree>
+      <p:nvGrpSpPr>
+        <p:cNvPr id="1" name=""/>
+        <p:cNvGrpSpPr/>
+        <p:nvPr/>
+      </p:nvGrpSpPr>
+      <p:grpSpPr/>
+      <p:sp>
+        <p:nvSpPr>
+          <p:cNvPr id="2" name="TextBox 1"/>
+          <p:cNvSpPr txBox="1"/>
+          <p:nvPr/>
+        </p:nvSpPr>
+        <p:spPr>
+          <a:xfrm>
+            <a:off x="566928" y="228600"/>
+            <a:ext cx="10972800" cy="228600"/>
+          </a:xfrm>
+          <a:prstGeom prst="rect">
+            <a:avLst/>
+          </a:prstGeom>
+          <a:noFill/>
+        </p:spPr>
+        <p:txBody>
+          <a:bodyPr wrap="square" lIns="0" rIns="0" tIns="0" bIns="0">
+            <a:noAutofit/>
+          </a:bodyPr>
+          <a:lstStyle/>
+          <a:p>
+            <a:pPr algn="l">
+              <a:lnSpc>
+                <a:spcPct val="108000"/>
+              </a:lnSpc>
+              <a:spcAft>
+                <a:spcPts val="0"/>
+              </a:spcAft>
+              <a:defRPr sz="1050" b="1">
+                <a:solidFill>
+                  <a:srgbClr val="284A63"/>
+                </a:solidFill>
+                <a:latin typeface="Arial"/>
+              </a:defRPr>
+            </a:pPr>
+            <a:r>
+              <a:t>PHỤ LỤC</a:t>
+            </a:r>
+          </a:p>
+        </p:txBody>
+      </p:sp>
+      <p:sp>
+        <p:nvSpPr>
+          <p:cNvPr id="3" name="TextBox 2"/>
+          <p:cNvSpPr txBox="1"/>
+          <p:nvPr/>
+        </p:nvSpPr>
+        <p:spPr>
+          <a:xfrm>
+            <a:off x="566928" y="658368"/>
+            <a:ext cx="10972800" cy="475488"/>
+          </a:xfrm>
+          <a:prstGeom prst="rect">
+            <a:avLst/>
+          </a:prstGeom>
+          <a:noFill/>
+        </p:spPr>
+        <p:txBody>
+          <a:bodyPr wrap="square" lIns="0" rIns="0" tIns="0" bIns="0">
+            <a:noAutofit/>
+          </a:bodyPr>
+          <a:lstStyle/>
+          <a:p>
+            <a:pPr algn="l">
+              <a:lnSpc>
+                <a:spcPct val="108000"/>
+              </a:lnSpc>
+              <a:spcAft>
+                <a:spcPts val="0"/>
+              </a:spcAft>
+              <a:defRPr sz="3000" b="1">
+                <a:solidFill>
+                  <a:srgbClr val="17212B"/>
+                </a:solidFill>
+                <a:latin typeface="Arial"/>
+              </a:defRPr>
+            </a:pPr>
+            <a:r>
+              <a:t>ERD tổng thể — 17 bảng</a:t>
+            </a:r>
+          </a:p>
+        </p:txBody>
+      </p:sp>
+      <p:cxnSp>
+        <p:nvCxnSpPr>
+          <p:cNvPr id="4" name="Connector 3"/>
+          <p:cNvCxnSpPr/>
+          <p:nvPr/>
+        </p:nvCxnSpPr>
+        <p:spPr>
+          <a:xfrm>
+            <a:off x="566928" y="1243584"/>
+            <a:ext cx="11045952" cy="0"/>
+          </a:xfrm>
+          <a:prstGeom prst="line">
+            <a:avLst/>
+          </a:prstGeom>
+          <a:ln w="14604">
+            <a:solidFill>
+              <a:srgbClr val="59636E"/>
+            </a:solidFill>
+          </a:ln>
+          <a:effectLst/>
+        </p:spPr>
+        <p:style>
+          <a:lnRef idx="2">
+            <a:schemeClr val="accent1"/>
+          </a:lnRef>
+          <a:fillRef idx="0">
+            <a:schemeClr val="accent1"/>
+          </a:fillRef>
+          <a:effectRef idx="0">
+            <a:schemeClr val="accent1"/>
+          </a:effectRef>
+          <a:fontRef idx="minor">
+            <a:schemeClr val="tx1"/>
+          </a:fontRef>
+        </p:style>
+      </p:cxnSp>
+      <p:cxnSp>
+        <p:nvCxnSpPr>
+          <p:cNvPr id="5" name="Connector 4"/>
+          <p:cNvCxnSpPr/>
+          <p:nvPr/>
+        </p:nvCxnSpPr>
+        <p:spPr>
+          <a:xfrm>
+            <a:off x="566928" y="6428232"/>
+            <a:ext cx="11045952" cy="0"/>
+          </a:xfrm>
+          <a:prstGeom prst="line">
+            <a:avLst/>
+          </a:prstGeom>
+          <a:ln w="14604">
+            <a:solidFill>
+              <a:srgbClr val="59636E"/>
+            </a:solidFill>
+          </a:ln>
+          <a:effectLst/>
+        </p:spPr>
+        <p:style>
+          <a:lnRef idx="2">
+            <a:schemeClr val="accent1"/>
+          </a:lnRef>
+          <a:fillRef idx="0">
+            <a:schemeClr val="accent1"/>
+          </a:fillRef>
+          <a:effectRef idx="0">
+            <a:schemeClr val="accent1"/>
+          </a:effectRef>
+          <a:fontRef idx="minor">
+            <a:schemeClr val="tx1"/>
+          </a:fontRef>
+        </p:style>
+      </p:cxnSp>
+      <p:sp>
+        <p:nvSpPr>
+          <p:cNvPr id="6" name="TextBox 5"/>
+          <p:cNvSpPr txBox="1"/>
+          <p:nvPr/>
+        </p:nvSpPr>
+        <p:spPr>
+          <a:xfrm>
+            <a:off x="566928" y="6537960"/>
+            <a:ext cx="10058400" cy="164592"/>
+          </a:xfrm>
+          <a:prstGeom prst="rect">
+            <a:avLst/>
+          </a:prstGeom>
+          <a:noFill/>
+        </p:spPr>
+        <p:txBody>
+          <a:bodyPr wrap="square" lIns="0" rIns="0" tIns="0" bIns="0">
+            <a:noAutofit/>
+          </a:bodyPr>
+          <a:lstStyle/>
+          <a:p>
+            <a:pPr algn="l">
+              <a:lnSpc>
+                <a:spcPct val="108000"/>
+              </a:lnSpc>
+              <a:spcAft>
+                <a:spcPts val="0"/>
+              </a:spcAft>
+              <a:defRPr sz="900" b="0">
+                <a:solidFill>
+                  <a:srgbClr val="59636E"/>
+                </a:solidFill>
+                <a:latin typeface="Arial"/>
+              </a:defRPr>
+            </a:pPr>
+            <a:r>
+              <a:t>QUẢN LÝ NHÀ TRỌ  |  PHÂN TÍCH YÊU CẦU VÀ THIẾT KẾ CSDL</a:t>
+            </a:r>
+          </a:p>
+        </p:txBody>
+      </p:sp>
+      <p:sp>
+        <p:nvSpPr>
+          <p:cNvPr id="7" name="TextBox 6"/>
+          <p:cNvSpPr txBox="1"/>
+          <p:nvPr/>
+        </p:nvSpPr>
+        <p:spPr>
+          <a:xfrm>
+            <a:off x="11064240" y="6510528"/>
+            <a:ext cx="548640" cy="228600"/>
+          </a:xfrm>
+          <a:prstGeom prst="rect">
+            <a:avLst/>
+          </a:prstGeom>
+          <a:noFill/>
+        </p:spPr>
+        <p:txBody>
+          <a:bodyPr wrap="square" lIns="0" rIns="0" tIns="0" bIns="0">
+            <a:noAutofit/>
+          </a:bodyPr>
+          <a:lstStyle/>
+          <a:p>
+            <a:pPr algn="r">
+              <a:lnSpc>
+                <a:spcPct val="108000"/>
+              </a:lnSpc>
+              <a:spcAft>
+                <a:spcPts val="0"/>
+              </a:spcAft>
+              <a:defRPr sz="1000" b="0">
+                <a:solidFill>
+                  <a:srgbClr val="59636E"/>
+                </a:solidFill>
+                <a:latin typeface="Arial"/>
+              </a:defRPr>
+            </a:pPr>
+            <a:r>
+              <a:t>22</a:t>
+            </a:r>
+          </a:p>
+        </p:txBody>
+      </p:sp>
+      <p:pic>
+        <p:nvPicPr>
+          <p:cNvPr id="8" name="Picture 7" descr="quanlytro-dbdiagram-official.png"/>
+          <p:cNvPicPr>
+            <a:picLocks noChangeAspect="1"/>
+          </p:cNvPicPr>
+          <p:nvPr/>
+        </p:nvPicPr>
+        <p:blipFill>
+          <a:blip r:embed="rId2"/>
+          <a:stretch>
+            <a:fillRect/>
+          </a:stretch>
+        </p:blipFill>
+        <p:spPr>
+          <a:xfrm>
+            <a:off x="1348761" y="1463040"/>
+            <a:ext cx="9494476" cy="4617720"/>
+          </a:xfrm>
+          <a:prstGeom prst="rect">
+            <a:avLst/>
+          </a:prstGeom>
+        </p:spPr>
+      </p:pic>
+      <p:sp>
+        <p:nvSpPr>
+          <p:cNvPr id="9" name="TextBox 8"/>
+          <p:cNvSpPr txBox="1"/>
+          <p:nvPr/>
+        </p:nvSpPr>
+        <p:spPr>
+          <a:xfrm>
+            <a:off x="731520" y="6144768"/>
+            <a:ext cx="10789920" cy="228600"/>
+          </a:xfrm>
+          <a:prstGeom prst="rect">
+            <a:avLst/>
+          </a:prstGeom>
+          <a:noFill/>
+        </p:spPr>
+        <p:txBody>
+          <a:bodyPr wrap="square" lIns="0" rIns="0" tIns="0" bIns="0">
+            <a:noAutofit/>
+          </a:bodyPr>
+          <a:lstStyle/>
+          <a:p>
+            <a:pPr algn="l">
+              <a:lnSpc>
+                <a:spcPct val="108000"/>
+              </a:lnSpc>
+              <a:spcAft>
+                <a:spcPts val="0"/>
+              </a:spcAft>
+              <a:defRPr sz="1300" b="0">
+                <a:solidFill>
+                  <a:srgbClr val="59636E"/>
+                </a:solidFill>
+                <a:latin typeface="Arial"/>
+              </a:defRPr>
+            </a:pPr>
+            <a:r>
+              <a:t>17 bảng • 28 khóa ngoại • Bản xuất từ dbdiagram.io</a:t>
+            </a:r>
+          </a:p>
+        </p:txBody>
+      </p:sp>
+    </p:spTree>
+  </p:cSld>
+  <p:clrMapOvr>
+    <a:masterClrMapping/>
+  </p:clrMapOvr>
+</p:sld>
+</file>
+
 <file path=ppt/slides/slide3.xml><?xml version="1.0" encoding="utf-8"?>
 <p:sld xmlns:a="http://schemas.openxmlformats.org/drawingml/2006/main" xmlns:p="http://schemas.openxmlformats.org/presentationml/2006/main" xmlns:r="http://schemas.openxmlformats.org/officeDocument/2006/relationships">
   <p:cSld>

</xml_diff>

<commit_message>
docs: review presentation and highlight public ERD for submission
</commit_message>
<xml_diff>
--- a/docs/thiet-ke-csdl-va-phan-tich-nghiep-vu.pptx
+++ b/docs/thiet-ke-csdl-va-phan-tich-nghiep-vu.pptx
@@ -3426,49 +3426,7 @@
         </p:nvSpPr>
         <p:spPr>
           <a:xfrm>
-            <a:off x="731520" y="3337560"/>
-            <a:ext cx="10607040" cy="640080"/>
-          </a:xfrm>
-          <a:prstGeom prst="rect">
-            <a:avLst/>
-          </a:prstGeom>
-          <a:noFill/>
-        </p:spPr>
-        <p:txBody>
-          <a:bodyPr wrap="square" lIns="0" rIns="0" tIns="0" bIns="0">
-            <a:noAutofit/>
-          </a:bodyPr>
-          <a:lstStyle/>
-          <a:p>
-            <a:pPr algn="l">
-              <a:lnSpc>
-                <a:spcPct val="108000"/>
-              </a:lnSpc>
-              <a:spcAft>
-                <a:spcPts val="0"/>
-              </a:spcAft>
-              <a:defRPr sz="2400" b="0">
-                <a:solidFill>
-                  <a:srgbClr val="17212B"/>
-                </a:solidFill>
-                <a:latin typeface="Arial"/>
-              </a:defRPr>
-            </a:pPr>
-            <a:r>
-              <a:t>Hợp đồng • Hóa đơn • Công nợ • Quyết toán</a:t>
-            </a:r>
-          </a:p>
-        </p:txBody>
-      </p:sp>
-      <p:sp>
-        <p:nvSpPr>
-          <p:cNvPr id="10" name="TextBox 9"/>
-          <p:cNvSpPr txBox="1"/>
-          <p:nvPr/>
-        </p:nvSpPr>
-        <p:spPr>
-          <a:xfrm>
-            <a:off x="731520" y="4572000"/>
+            <a:off x="731520" y="3429000"/>
             <a:ext cx="10607040" cy="822960"/>
           </a:xfrm>
           <a:prstGeom prst="rect">
@@ -3516,7 +3474,259 @@
               </a:defRPr>
             </a:pPr>
             <a:r>
-              <a:t>Nhóm: ………………………………</a:t>
+              <a:t>Nhóm: gehihi</a:t>
+            </a:r>
+          </a:p>
+        </p:txBody>
+      </p:sp>
+      <p:sp>
+        <p:nvSpPr>
+          <p:cNvPr id="10" name="TextBox 9"/>
+          <p:cNvSpPr txBox="1"/>
+          <p:nvPr/>
+        </p:nvSpPr>
+        <p:spPr>
+          <a:xfrm>
+            <a:off x="731520" y="4434840"/>
+            <a:ext cx="5303520" cy="338328"/>
+          </a:xfrm>
+          <a:prstGeom prst="rect">
+            <a:avLst/>
+          </a:prstGeom>
+          <a:noFill/>
+        </p:spPr>
+        <p:txBody>
+          <a:bodyPr wrap="square" lIns="0" rIns="0" tIns="0" bIns="0">
+            <a:noAutofit/>
+          </a:bodyPr>
+          <a:lstStyle/>
+          <a:p>
+            <a:pPr algn="l">
+              <a:lnSpc>
+                <a:spcPct val="108000"/>
+              </a:lnSpc>
+              <a:spcAft>
+                <a:spcPts val="0"/>
+              </a:spcAft>
+              <a:defRPr sz="1900" b="0">
+                <a:solidFill>
+                  <a:srgbClr val="17212B"/>
+                </a:solidFill>
+                <a:latin typeface="Arial"/>
+              </a:defRPr>
+            </a:pPr>
+            <a:r>
+              <a:t>Nguyễn Doãn Huy</a:t>
+            </a:r>
+          </a:p>
+        </p:txBody>
+      </p:sp>
+      <p:sp>
+        <p:nvSpPr>
+          <p:cNvPr id="11" name="TextBox 10"/>
+          <p:cNvSpPr txBox="1"/>
+          <p:nvPr/>
+        </p:nvSpPr>
+        <p:spPr>
+          <a:xfrm>
+            <a:off x="731520" y="4873752"/>
+            <a:ext cx="5303520" cy="338328"/>
+          </a:xfrm>
+          <a:prstGeom prst="rect">
+            <a:avLst/>
+          </a:prstGeom>
+          <a:noFill/>
+        </p:spPr>
+        <p:txBody>
+          <a:bodyPr wrap="square" lIns="0" rIns="0" tIns="0" bIns="0">
+            <a:noAutofit/>
+          </a:bodyPr>
+          <a:lstStyle/>
+          <a:p>
+            <a:pPr algn="l">
+              <a:lnSpc>
+                <a:spcPct val="108000"/>
+              </a:lnSpc>
+              <a:spcAft>
+                <a:spcPts val="0"/>
+              </a:spcAft>
+              <a:defRPr sz="1900" b="0">
+                <a:solidFill>
+                  <a:srgbClr val="17212B"/>
+                </a:solidFill>
+                <a:latin typeface="Arial"/>
+              </a:defRPr>
+            </a:pPr>
+            <a:r>
+              <a:t>Phan Văn Hiếu</a:t>
+            </a:r>
+          </a:p>
+        </p:txBody>
+      </p:sp>
+      <p:sp>
+        <p:nvSpPr>
+          <p:cNvPr id="12" name="TextBox 11"/>
+          <p:cNvSpPr txBox="1"/>
+          <p:nvPr/>
+        </p:nvSpPr>
+        <p:spPr>
+          <a:xfrm>
+            <a:off x="731520" y="5312664"/>
+            <a:ext cx="5303520" cy="338328"/>
+          </a:xfrm>
+          <a:prstGeom prst="rect">
+            <a:avLst/>
+          </a:prstGeom>
+          <a:noFill/>
+        </p:spPr>
+        <p:txBody>
+          <a:bodyPr wrap="square" lIns="0" rIns="0" tIns="0" bIns="0">
+            <a:noAutofit/>
+          </a:bodyPr>
+          <a:lstStyle/>
+          <a:p>
+            <a:pPr algn="l">
+              <a:lnSpc>
+                <a:spcPct val="108000"/>
+              </a:lnSpc>
+              <a:spcAft>
+                <a:spcPts val="0"/>
+              </a:spcAft>
+              <a:defRPr sz="1900" b="0">
+                <a:solidFill>
+                  <a:srgbClr val="17212B"/>
+                </a:solidFill>
+                <a:latin typeface="Arial"/>
+              </a:defRPr>
+            </a:pPr>
+            <a:r>
+              <a:t>Nguyễn Trần Tuấn Khôi</a:t>
+            </a:r>
+          </a:p>
+        </p:txBody>
+      </p:sp>
+      <p:sp>
+        <p:nvSpPr>
+          <p:cNvPr id="13" name="TextBox 12"/>
+          <p:cNvSpPr txBox="1"/>
+          <p:nvPr/>
+        </p:nvSpPr>
+        <p:spPr>
+          <a:xfrm>
+            <a:off x="6217920" y="4434840"/>
+            <a:ext cx="5303520" cy="338328"/>
+          </a:xfrm>
+          <a:prstGeom prst="rect">
+            <a:avLst/>
+          </a:prstGeom>
+          <a:noFill/>
+        </p:spPr>
+        <p:txBody>
+          <a:bodyPr wrap="square" lIns="0" rIns="0" tIns="0" bIns="0">
+            <a:noAutofit/>
+          </a:bodyPr>
+          <a:lstStyle/>
+          <a:p>
+            <a:pPr algn="l">
+              <a:lnSpc>
+                <a:spcPct val="108000"/>
+              </a:lnSpc>
+              <a:spcAft>
+                <a:spcPts val="0"/>
+              </a:spcAft>
+              <a:defRPr sz="1900" b="0">
+                <a:solidFill>
+                  <a:srgbClr val="17212B"/>
+                </a:solidFill>
+                <a:latin typeface="Arial"/>
+              </a:defRPr>
+            </a:pPr>
+            <a:r>
+              <a:t>Nie Phương Anh</a:t>
+            </a:r>
+          </a:p>
+        </p:txBody>
+      </p:sp>
+      <p:sp>
+        <p:nvSpPr>
+          <p:cNvPr id="14" name="TextBox 13"/>
+          <p:cNvSpPr txBox="1"/>
+          <p:nvPr/>
+        </p:nvSpPr>
+        <p:spPr>
+          <a:xfrm>
+            <a:off x="6217920" y="4873752"/>
+            <a:ext cx="5303520" cy="338328"/>
+          </a:xfrm>
+          <a:prstGeom prst="rect">
+            <a:avLst/>
+          </a:prstGeom>
+          <a:noFill/>
+        </p:spPr>
+        <p:txBody>
+          <a:bodyPr wrap="square" lIns="0" rIns="0" tIns="0" bIns="0">
+            <a:noAutofit/>
+          </a:bodyPr>
+          <a:lstStyle/>
+          <a:p>
+            <a:pPr algn="l">
+              <a:lnSpc>
+                <a:spcPct val="108000"/>
+              </a:lnSpc>
+              <a:spcAft>
+                <a:spcPts val="0"/>
+              </a:spcAft>
+              <a:defRPr sz="1900" b="0">
+                <a:solidFill>
+                  <a:srgbClr val="17212B"/>
+                </a:solidFill>
+                <a:latin typeface="Arial"/>
+              </a:defRPr>
+            </a:pPr>
+            <a:r>
+              <a:t>Trần Đức Nguyên</a:t>
+            </a:r>
+          </a:p>
+        </p:txBody>
+      </p:sp>
+      <p:sp>
+        <p:nvSpPr>
+          <p:cNvPr id="15" name="TextBox 14"/>
+          <p:cNvSpPr txBox="1"/>
+          <p:nvPr/>
+        </p:nvSpPr>
+        <p:spPr>
+          <a:xfrm>
+            <a:off x="6217920" y="5312664"/>
+            <a:ext cx="5303520" cy="338328"/>
+          </a:xfrm>
+          <a:prstGeom prst="rect">
+            <a:avLst/>
+          </a:prstGeom>
+          <a:noFill/>
+        </p:spPr>
+        <p:txBody>
+          <a:bodyPr wrap="square" lIns="0" rIns="0" tIns="0" bIns="0">
+            <a:noAutofit/>
+          </a:bodyPr>
+          <a:lstStyle/>
+          <a:p>
+            <a:pPr algn="l">
+              <a:lnSpc>
+                <a:spcPct val="108000"/>
+              </a:lnSpc>
+              <a:spcAft>
+                <a:spcPts val="0"/>
+              </a:spcAft>
+              <a:defRPr sz="1900" b="0">
+                <a:solidFill>
+                  <a:srgbClr val="17212B"/>
+                </a:solidFill>
+                <a:latin typeface="Arial"/>
+              </a:defRPr>
+            </a:pPr>
+            <a:r>
+              <a:t>Nguyễn Quang Trung</a:t>
             </a:r>
           </a:p>
         </p:txBody>
@@ -5925,7 +6135,7 @@
               </a:defRPr>
             </a:pPr>
             <a:r>
-              <a:t>Một người dùng chung hồ sơ qua nhiều lần cư trú; không sao chép họ tên vào bảng thành viên.</a:t>
+              <a:t>Một người thuê dùng lại hồ sơ qua nhiều lần cư trú; không chép họ tên vào bảng thành viên.</a:t>
             </a:r>
           </a:p>
         </p:txBody>
@@ -9400,7 +9610,7 @@
               </a:defRPr>
             </a:pPr>
             <a:r>
-              <a:t>PK  id</a:t>
+              <a:t>PK  id; FK  invoice_id</a:t>
             </a:r>
           </a:p>
         </p:txBody>
@@ -9442,7 +9652,7 @@
               </a:defRPr>
             </a:pPr>
             <a:r>
-              <a:t>FK  invoice_id</a:t>
+              <a:t>FK  service_item_id (NULL)</a:t>
             </a:r>
           </a:p>
         </p:txBody>
@@ -9484,7 +9694,7 @@
               </a:defRPr>
             </a:pPr>
             <a:r>
-              <a:t>FK  service_item_id / reading</a:t>
+              <a:t>FK/UQ  meter_reading_id (NULL)</a:t>
             </a:r>
           </a:p>
         </p:txBody>
@@ -9526,7 +9736,7 @@
               </a:defRPr>
             </a:pPr>
             <a:r>
-              <a:t>giá snapshot; ngày tính phí</a:t>
+              <a:t>giá snapshot; ngày/ngày-người</a:t>
             </a:r>
           </a:p>
         </p:txBody>
@@ -10264,7 +10474,7 @@
               </a:defRPr>
             </a:pPr>
             <a:r>
-              <a:t>chỉ số đã được khóa</a:t>
+              <a:t>khóa khi đã dùng ở hóa đơn</a:t>
             </a:r>
           </a:p>
         </p:txBody>
@@ -11095,7 +11305,7 @@
               </a:defRPr>
             </a:pPr>
             <a:r>
-              <a:t>0..1</a:t>
+              <a:t>0..1 : 0..1</a:t>
             </a:r>
           </a:p>
         </p:txBody>
@@ -11696,7 +11906,7 @@
                         </a:defRPr>
                       </a:pPr>
                       <a:r>
-                        <a:t>Thập phân chính xác; làm tròn thành tiền</a:t>
+                        <a:t>Số thập phân chính xác; nợ snapshot: NUMERIC(14,2)</a:t>
                       </a:r>
                     </a:p>
                   </a:txBody>
@@ -12666,7 +12876,7 @@
                         </a:defRPr>
                       </a:pPr>
                       <a:r>
-                        <a:t>Không chồng khoảng thuê phòng hoặc khoảng cư trú của cùng thành viên</a:t>
+                        <a:t>Không trùng khoảng thuê cùng phòng; cùng người không trùng khoảng trong một hợp đồng</a:t>
                       </a:r>
                     </a:p>
                   </a:txBody>
@@ -13019,7 +13229,7 @@
         </p:nvGraphicFramePr>
         <p:xfrm>
           <a:off x="594360" y="1600200"/>
-          <a:ext cx="10972799" cy="4389120"/>
+          <a:ext cx="10972799" cy="4480560"/>
         </p:xfrm>
         <a:graphic>
           <a:graphicData uri="http://schemas.openxmlformats.org/drawingml/2006/table">
@@ -13032,7 +13242,7 @@
                 <a:gridCol w="4754880"/>
                 <a:gridCol w="3749039"/>
               </a:tblGrid>
-              <a:tr h="731520">
+              <a:tr h="640080">
                 <a:tc>
                   <a:txBody>
                     <a:bodyPr wrap="square"/>
@@ -13045,7 +13255,7 @@
                         <a:spcAft>
                           <a:spcPts val="100"/>
                         </a:spcAft>
-                        <a:defRPr sz="1800" b="1">
+                        <a:defRPr sz="1700" b="1">
                           <a:solidFill>
                             <a:srgbClr val="FFFFFF"/>
                           </a:solidFill>
@@ -13075,7 +13285,7 @@
                         <a:spcAft>
                           <a:spcPts val="100"/>
                         </a:spcAft>
-                        <a:defRPr sz="1800" b="1">
+                        <a:defRPr sz="1700" b="1">
                           <a:solidFill>
                             <a:srgbClr val="FFFFFF"/>
                           </a:solidFill>
@@ -13105,7 +13315,7 @@
                         <a:spcAft>
                           <a:spcPts val="100"/>
                         </a:spcAft>
-                        <a:defRPr sz="1800" b="1">
+                        <a:defRPr sz="1700" b="1">
                           <a:solidFill>
                             <a:srgbClr val="FFFFFF"/>
                           </a:solidFill>
@@ -13124,7 +13334,7 @@
                   </a:tcPr>
                 </a:tc>
               </a:tr>
-              <a:tr h="731520">
+              <a:tr h="640080">
                 <a:tc>
                   <a:txBody>
                     <a:bodyPr wrap="square"/>
@@ -13137,7 +13347,99 @@
                         <a:spcAft>
                           <a:spcPts val="100"/>
                         </a:spcAft>
-                        <a:defRPr sz="1800" b="0">
+                        <a:defRPr sz="1700" b="0">
+                          <a:solidFill>
+                            <a:srgbClr val="17212B"/>
+                          </a:solidFill>
+                          <a:latin typeface="Arial"/>
+                        </a:defRPr>
+                      </a:pPr>
+                      <a:r>
+                        <a:t>0..1–0..1</a:t>
+                      </a:r>
+                    </a:p>
+                  </a:txBody>
+                  <a:tcPr marL="118872" marR="118872" marT="54864" marB="54864" anchor="ctr">
+                    <a:solidFill>
+                      <a:srgbClr val="FFFFFF"/>
+                    </a:solidFill>
+                  </a:tcPr>
+                </a:tc>
+                <a:tc>
+                  <a:txBody>
+                    <a:bodyPr wrap="square"/>
+                    <a:lstStyle/>
+                    <a:p>
+                      <a:pPr>
+                        <a:lnSpc>
+                          <a:spcPct val="102000"/>
+                        </a:lnSpc>
+                        <a:spcAft>
+                          <a:spcPts val="100"/>
+                        </a:spcAft>
+                        <a:defRPr sz="1700" b="0">
+                          <a:solidFill>
+                            <a:srgbClr val="17212B"/>
+                          </a:solidFill>
+                          <a:latin typeface="Arial"/>
+                        </a:defRPr>
+                      </a:pPr>
+                      <a:r>
+                        <a:t>Tài khoản–hồ sơ; chỉ số–dòng hóa đơn</a:t>
+                      </a:r>
+                    </a:p>
+                  </a:txBody>
+                  <a:tcPr marL="118872" marR="118872" marT="54864" marB="54864" anchor="ctr">
+                    <a:solidFill>
+                      <a:srgbClr val="FFFFFF"/>
+                    </a:solidFill>
+                  </a:tcPr>
+                </a:tc>
+                <a:tc>
+                  <a:txBody>
+                    <a:bodyPr wrap="square"/>
+                    <a:lstStyle/>
+                    <a:p>
+                      <a:pPr>
+                        <a:lnSpc>
+                          <a:spcPct val="102000"/>
+                        </a:lnSpc>
+                        <a:spcAft>
+                          <a:spcPts val="100"/>
+                        </a:spcAft>
+                        <a:defRPr sz="1700" b="0">
+                          <a:solidFill>
+                            <a:srgbClr val="17212B"/>
+                          </a:solidFill>
+                          <a:latin typeface="Arial"/>
+                        </a:defRPr>
+                      </a:pPr>
+                      <a:r>
+                        <a:t>FK cho phép NULL + UNIQUE</a:t>
+                      </a:r>
+                    </a:p>
+                  </a:txBody>
+                  <a:tcPr marL="118872" marR="118872" marT="54864" marB="54864" anchor="ctr">
+                    <a:solidFill>
+                      <a:srgbClr val="FFFFFF"/>
+                    </a:solidFill>
+                  </a:tcPr>
+                </a:tc>
+              </a:tr>
+              <a:tr h="640080">
+                <a:tc>
+                  <a:txBody>
+                    <a:bodyPr wrap="square"/>
+                    <a:lstStyle/>
+                    <a:p>
+                      <a:pPr>
+                        <a:lnSpc>
+                          <a:spcPct val="102000"/>
+                        </a:lnSpc>
+                        <a:spcAft>
+                          <a:spcPts val="100"/>
+                        </a:spcAft>
+                        <a:defRPr sz="1700" b="0">
                           <a:solidFill>
                             <a:srgbClr val="17212B"/>
                           </a:solidFill>
@@ -13167,7 +13469,7 @@
                         <a:spcAft>
                           <a:spcPts val="100"/>
                         </a:spcAft>
-                        <a:defRPr sz="1800" b="0">
+                        <a:defRPr sz="1700" b="0">
                           <a:solidFill>
                             <a:srgbClr val="17212B"/>
                           </a:solidFill>
@@ -13175,7 +13477,7 @@
                         </a:defRPr>
                       </a:pPr>
                       <a:r>
-                        <a:t>Tài khoản–hồ sơ; hợp đồng–quyết toán</a:t>
+                        <a:t>Hợp đồng–quyết toán; chỉ số–cảnh báo</a:t>
                       </a:r>
                     </a:p>
                   </a:txBody>
@@ -13197,7 +13499,7 @@
                         <a:spcAft>
                           <a:spcPts val="100"/>
                         </a:spcAft>
-                        <a:defRPr sz="1800" b="0">
+                        <a:defRPr sz="1700" b="0">
                           <a:solidFill>
                             <a:srgbClr val="17212B"/>
                           </a:solidFill>
@@ -13205,7 +13507,7 @@
                         </a:defRPr>
                       </a:pPr>
                       <a:r>
-                        <a:t>UNIQUE trên FK; liên kết tùy chọn</a:t>
+                        <a:t>FK NOT NULL + UNIQUE ở bảng con</a:t>
                       </a:r>
                     </a:p>
                   </a:txBody>
@@ -13216,7 +13518,7 @@
                   </a:tcPr>
                 </a:tc>
               </a:tr>
-              <a:tr h="731520">
+              <a:tr h="640080">
                 <a:tc>
                   <a:txBody>
                     <a:bodyPr wrap="square"/>
@@ -13229,7 +13531,7 @@
                         <a:spcAft>
                           <a:spcPts val="100"/>
                         </a:spcAft>
-                        <a:defRPr sz="1800" b="0">
+                        <a:defRPr sz="1700" b="0">
                           <a:solidFill>
                             <a:srgbClr val="17212B"/>
                           </a:solidFill>
@@ -13259,7 +13561,7 @@
                         <a:spcAft>
                           <a:spcPts val="100"/>
                         </a:spcAft>
-                        <a:defRPr sz="1800" b="0">
+                        <a:defRPr sz="1700" b="0">
                           <a:solidFill>
                             <a:srgbClr val="17212B"/>
                           </a:solidFill>
@@ -13289,7 +13591,7 @@
                         <a:spcAft>
                           <a:spcPts val="100"/>
                         </a:spcAft>
-                        <a:defRPr sz="1800" b="0">
+                        <a:defRPr sz="1700" b="0">
                           <a:solidFill>
                             <a:srgbClr val="17212B"/>
                           </a:solidFill>
@@ -13308,7 +13610,7 @@
                   </a:tcPr>
                 </a:tc>
               </a:tr>
-              <a:tr h="731520">
+              <a:tr h="640080">
                 <a:tc>
                   <a:txBody>
                     <a:bodyPr wrap="square"/>
@@ -13321,7 +13623,7 @@
                         <a:spcAft>
                           <a:spcPts val="100"/>
                         </a:spcAft>
-                        <a:defRPr sz="1800" b="0">
+                        <a:defRPr sz="1700" b="0">
                           <a:solidFill>
                             <a:srgbClr val="17212B"/>
                           </a:solidFill>
@@ -13351,7 +13653,7 @@
                         <a:spcAft>
                           <a:spcPts val="100"/>
                         </a:spcAft>
-                        <a:defRPr sz="1800" b="0">
+                        <a:defRPr sz="1700" b="0">
                           <a:solidFill>
                             <a:srgbClr val="17212B"/>
                           </a:solidFill>
@@ -13381,7 +13683,7 @@
                         <a:spcAft>
                           <a:spcPts val="100"/>
                         </a:spcAft>
-                        <a:defRPr sz="1800" b="0">
+                        <a:defRPr sz="1700" b="0">
                           <a:solidFill>
                             <a:srgbClr val="17212B"/>
                           </a:solidFill>
@@ -13400,7 +13702,7 @@
                   </a:tcPr>
                 </a:tc>
               </a:tr>
-              <a:tr h="731520">
+              <a:tr h="640080">
                 <a:tc>
                   <a:txBody>
                     <a:bodyPr wrap="square"/>
@@ -13413,7 +13715,7 @@
                         <a:spcAft>
                           <a:spcPts val="100"/>
                         </a:spcAft>
-                        <a:defRPr sz="1800" b="0">
+                        <a:defRPr sz="1700" b="0">
                           <a:solidFill>
                             <a:srgbClr val="17212B"/>
                           </a:solidFill>
@@ -13443,7 +13745,7 @@
                         <a:spcAft>
                           <a:spcPts val="100"/>
                         </a:spcAft>
-                        <a:defRPr sz="1800" b="0">
+                        <a:defRPr sz="1700" b="0">
                           <a:solidFill>
                             <a:srgbClr val="17212B"/>
                           </a:solidFill>
@@ -13473,7 +13775,7 @@
                         <a:spcAft>
                           <a:spcPts val="100"/>
                         </a:spcAft>
-                        <a:defRPr sz="1800" b="0">
+                        <a:defRPr sz="1700" b="0">
                           <a:solidFill>
                             <a:srgbClr val="17212B"/>
                           </a:solidFill>
@@ -13492,7 +13794,7 @@
                   </a:tcPr>
                 </a:tc>
               </a:tr>
-              <a:tr h="731520">
+              <a:tr h="640080">
                 <a:tc>
                   <a:txBody>
                     <a:bodyPr wrap="square"/>
@@ -13505,7 +13807,7 @@
                         <a:spcAft>
                           <a:spcPts val="100"/>
                         </a:spcAft>
-                        <a:defRPr sz="1800" b="0">
+                        <a:defRPr sz="1700" b="0">
                           <a:solidFill>
                             <a:srgbClr val="17212B"/>
                           </a:solidFill>
@@ -13535,7 +13837,7 @@
                         <a:spcAft>
                           <a:spcPts val="100"/>
                         </a:spcAft>
-                        <a:defRPr sz="1800" b="0">
+                        <a:defRPr sz="1700" b="0">
                           <a:solidFill>
                             <a:srgbClr val="17212B"/>
                           </a:solidFill>
@@ -13565,7 +13867,7 @@
                         <a:spcAft>
                           <a:spcPts val="100"/>
                         </a:spcAft>
-                        <a:defRPr sz="1800" b="0">
+                        <a:defRPr sz="1700" b="0">
                           <a:solidFill>
                             <a:srgbClr val="17212B"/>
                           </a:solidFill>
@@ -13890,7 +14192,7 @@
                         <a:spcAft>
                           <a:spcPts val="100"/>
                         </a:spcAft>
-                        <a:defRPr sz="1800" b="1">
+                        <a:defRPr sz="1700" b="1">
                           <a:solidFill>
                             <a:srgbClr val="FFFFFF"/>
                           </a:solidFill>
@@ -13920,7 +14222,7 @@
                         <a:spcAft>
                           <a:spcPts val="100"/>
                         </a:spcAft>
-                        <a:defRPr sz="1800" b="1">
+                        <a:defRPr sz="1700" b="1">
                           <a:solidFill>
                             <a:srgbClr val="FFFFFF"/>
                           </a:solidFill>
@@ -13950,7 +14252,7 @@
                         <a:spcAft>
                           <a:spcPts val="100"/>
                         </a:spcAft>
-                        <a:defRPr sz="1800" b="1">
+                        <a:defRPr sz="1700" b="1">
                           <a:solidFill>
                             <a:srgbClr val="FFFFFF"/>
                           </a:solidFill>
@@ -13982,7 +14284,7 @@
                         <a:spcAft>
                           <a:spcPts val="100"/>
                         </a:spcAft>
-                        <a:defRPr sz="1800" b="0">
+                        <a:defRPr sz="1700" b="0">
                           <a:solidFill>
                             <a:srgbClr val="17212B"/>
                           </a:solidFill>
@@ -14012,7 +14314,7 @@
                         <a:spcAft>
                           <a:spcPts val="100"/>
                         </a:spcAft>
-                        <a:defRPr sz="1800" b="0">
+                        <a:defRPr sz="1700" b="0">
                           <a:solidFill>
                             <a:srgbClr val="17212B"/>
                           </a:solidFill>
@@ -14042,7 +14344,7 @@
                         <a:spcAft>
                           <a:spcPts val="100"/>
                         </a:spcAft>
-                        <a:defRPr sz="1800" b="0">
+                        <a:defRPr sz="1700" b="0">
                           <a:solidFill>
                             <a:srgbClr val="17212B"/>
                           </a:solidFill>
@@ -14074,7 +14376,7 @@
                         <a:spcAft>
                           <a:spcPts val="100"/>
                         </a:spcAft>
-                        <a:defRPr sz="1800" b="0">
+                        <a:defRPr sz="1700" b="0">
                           <a:solidFill>
                             <a:srgbClr val="17212B"/>
                           </a:solidFill>
@@ -14104,7 +14406,7 @@
                         <a:spcAft>
                           <a:spcPts val="100"/>
                         </a:spcAft>
-                        <a:defRPr sz="1800" b="0">
+                        <a:defRPr sz="1700" b="0">
                           <a:solidFill>
                             <a:srgbClr val="17212B"/>
                           </a:solidFill>
@@ -14112,7 +14414,7 @@
                         </a:defRPr>
                       </a:pPr>
                       <a:r>
-                        <a:t>Thông tin chỉ phụ thuộc một phần khóa ghép</a:t>
+                        <a:t>Thuộc tính phi khóa phụ thuộc một phần khóa ứng viên ghép</a:t>
                       </a:r>
                     </a:p>
                   </a:txBody>
@@ -14134,7 +14436,7 @@
                         <a:spcAft>
                           <a:spcPts val="100"/>
                         </a:spcAft>
-                        <a:defRPr sz="1800" b="0">
+                        <a:defRPr sz="1700" b="0">
                           <a:solidFill>
                             <a:srgbClr val="17212B"/>
                           </a:solidFill>
@@ -14142,7 +14444,7 @@
                         </a:defRPr>
                       </a:pPr>
                       <a:r>
-                        <a:t>Không lưu họ tên ở thành viên; không lưu room_id ở chỉ số</a:t>
+                        <a:t>tenant_id chỉ là một phần khóa cư trú: họ tên lưu tại tenant_profiles</a:t>
                       </a:r>
                     </a:p>
                   </a:txBody>
@@ -14166,7 +14468,7 @@
                         <a:spcAft>
                           <a:spcPts val="100"/>
                         </a:spcAft>
-                        <a:defRPr sz="1800" b="0">
+                        <a:defRPr sz="1700" b="0">
                           <a:solidFill>
                             <a:srgbClr val="17212B"/>
                           </a:solidFill>
@@ -14196,7 +14498,7 @@
                         <a:spcAft>
                           <a:spcPts val="100"/>
                         </a:spcAft>
-                        <a:defRPr sz="1800" b="0">
+                        <a:defRPr sz="1700" b="0">
                           <a:solidFill>
                             <a:srgbClr val="17212B"/>
                           </a:solidFill>
@@ -14204,7 +14506,7 @@
                         </a:defRPr>
                       </a:pPr>
                       <a:r>
-                        <a:t>Thông tin danh mục lặp qua bảng quan hệ</a:t>
+                        <a:t>Phụ thuộc bắc cầu qua thuộc tính không phải siêu khóa</a:t>
                       </a:r>
                     </a:p>
                   </a:txBody>
@@ -14226,7 +14528,7 @@
                         <a:spcAft>
                           <a:spcPts val="100"/>
                         </a:spcAft>
-                        <a:defRPr sz="1800" b="0">
+                        <a:defRPr sz="1700" b="0">
                           <a:solidFill>
                             <a:srgbClr val="17212B"/>
                           </a:solidFill>
@@ -14234,7 +14536,7 @@
                         </a:defRPr>
                       </a:pPr>
                       <a:r>
-                        <a:t>Hồ sơ người và danh mục dịch vụ lưu tại thực thể riêng</a:t>
+                        <a:t>Sự cố chỉ lưu contract_id; suy ra room_id và property_id qua JOIN</a:t>
                       </a:r>
                     </a:p>
                   </a:txBody>
@@ -14258,7 +14560,7 @@
                         <a:spcAft>
                           <a:spcPts val="100"/>
                         </a:spcAft>
-                        <a:defRPr sz="1800" b="0">
+                        <a:defRPr sz="1700" b="0">
                           <a:solidFill>
                             <a:srgbClr val="17212B"/>
                           </a:solidFill>
@@ -14288,7 +14590,7 @@
                         <a:spcAft>
                           <a:spcPts val="100"/>
                         </a:spcAft>
-                        <a:defRPr sz="1800" b="0">
+                        <a:defRPr sz="1700" b="0">
                           <a:solidFill>
                             <a:srgbClr val="17212B"/>
                           </a:solidFill>
@@ -14318,7 +14620,7 @@
                         <a:spcAft>
                           <a:spcPts val="100"/>
                         </a:spcAft>
-                        <a:defRPr sz="1800" b="0">
+                        <a:defRPr sz="1700" b="0">
                           <a:solidFill>
                             <a:srgbClr val="17212B"/>
                           </a:solidFill>
@@ -14980,7 +15282,7 @@
               </a:defRPr>
             </a:pPr>
             <a:r>
-              <a:t>Tên, đơn vị và giá snapshot là dữ kiện tại lúc lập hóa đơn; không đổi theo danh mục hiện tại.</a:t>
+              <a:t>Snapshot tên, đơn vị, giá ghi nhận tại lúc lập hóa đơn; đổi danh mục không đổi hóa đơn cũ.</a:t>
             </a:r>
           </a:p>
         </p:txBody>
@@ -15830,48 +16132,6 @@
           </a:graphicData>
         </a:graphic>
       </p:graphicFrame>
-      <p:sp>
-        <p:nvSpPr>
-          <p:cNvPr id="9" name="TextBox 8"/>
-          <p:cNvSpPr txBox="1"/>
-          <p:nvPr/>
-        </p:nvSpPr>
-        <p:spPr>
-          <a:xfrm>
-            <a:off x="731520" y="6053328"/>
-            <a:ext cx="10789920" cy="274320"/>
-          </a:xfrm>
-          <a:prstGeom prst="rect">
-            <a:avLst/>
-          </a:prstGeom>
-          <a:noFill/>
-        </p:spPr>
-        <p:txBody>
-          <a:bodyPr wrap="square" lIns="0" rIns="0" tIns="0" bIns="0">
-            <a:noAutofit/>
-          </a:bodyPr>
-          <a:lstStyle/>
-          <a:p>
-            <a:pPr algn="l">
-              <a:lnSpc>
-                <a:spcPct val="108000"/>
-              </a:lnSpc>
-              <a:spcAft>
-                <a:spcPts val="0"/>
-              </a:spcAft>
-              <a:defRPr sz="1600" b="1">
-                <a:solidFill>
-                  <a:srgbClr val="284A63"/>
-                </a:solidFill>
-                <a:latin typeface="Arial"/>
-              </a:defRPr>
-            </a:pPr>
-            <a:r>
-              <a:t>PostgreSQL: 40 ca đạt; thu đồng thời 600 + 600 trên nợ 1.000 → nhận một lần, còn 400.</a:t>
-            </a:r>
-          </a:p>
-        </p:txBody>
-      </p:sp>
     </p:spTree>
   </p:cSld>
   <p:clrMapOvr>
@@ -16798,6 +17058,48 @@
           </a:p>
         </p:txBody>
       </p:sp>
+      <p:sp>
+        <p:nvSpPr>
+          <p:cNvPr id="11" name="TextBox 10"/>
+          <p:cNvSpPr txBox="1"/>
+          <p:nvPr/>
+        </p:nvSpPr>
+        <p:spPr>
+          <a:xfrm>
+            <a:off x="731520" y="6080760"/>
+            <a:ext cx="10881360" cy="201168"/>
+          </a:xfrm>
+          <a:prstGeom prst="rect">
+            <a:avLst/>
+          </a:prstGeom>
+          <a:noFill/>
+        </p:spPr>
+        <p:txBody>
+          <a:bodyPr wrap="square" lIns="0" rIns="0" tIns="0" bIns="0">
+            <a:noAutofit/>
+          </a:bodyPr>
+          <a:lstStyle/>
+          <a:p>
+            <a:pPr algn="l">
+              <a:lnSpc>
+                <a:spcPct val="108000"/>
+              </a:lnSpc>
+              <a:spcAft>
+                <a:spcPts val="0"/>
+              </a:spcAft>
+              <a:defRPr sz="1350" b="0">
+                <a:solidFill>
+                  <a:srgbClr val="59636E"/>
+                </a:solidFill>
+                <a:latin typeface="Arial"/>
+              </a:defRPr>
+            </a:pPr>
+            <a:r>
+              <a:t>Minh họa: trả ngày 01/10/2026; các kỳ trước đã thanh toán, không có khoản nợ khác.</a:t>
+            </a:r>
+          </a:p>
+        </p:txBody>
+      </p:sp>
     </p:spTree>
   </p:cSld>
   <p:clrMapOvr>
@@ -17550,7 +17852,7 @@
         </p:nvGraphicFramePr>
         <p:xfrm>
           <a:off x="594360" y="1600200"/>
-          <a:ext cx="10972800" cy="4114800"/>
+          <a:ext cx="10972800" cy="4160520"/>
         </p:xfrm>
         <a:graphic>
           <a:graphicData uri="http://schemas.openxmlformats.org/drawingml/2006/table">
@@ -17559,12 +17861,12 @@
                 <a:tableStyleId>{5C22544A-7EE6-4342-B048-85BDC9FD1C3A}</a:tableStyleId>
               </a:tblPr>
               <a:tblGrid>
-                <a:gridCol w="2926080"/>
-                <a:gridCol w="4023360"/>
-                <a:gridCol w="2377440"/>
-                <a:gridCol w="1645920"/>
+                <a:gridCol w="3291840"/>
+                <a:gridCol w="3840480"/>
+                <a:gridCol w="2286000"/>
+                <a:gridCol w="1554480"/>
               </a:tblGrid>
-              <a:tr h="822960">
+              <a:tr h="594360">
                 <a:tc>
                   <a:txBody>
                     <a:bodyPr wrap="square"/>
@@ -17577,7 +17879,7 @@
                         <a:spcAft>
                           <a:spcPts val="100"/>
                         </a:spcAft>
-                        <a:defRPr sz="1800" b="1">
+                        <a:defRPr sz="1550" b="1">
                           <a:solidFill>
                             <a:srgbClr val="FFFFFF"/>
                           </a:solidFill>
@@ -17607,7 +17909,7 @@
                         <a:spcAft>
                           <a:spcPts val="100"/>
                         </a:spcAft>
-                        <a:defRPr sz="1800" b="1">
+                        <a:defRPr sz="1550" b="1">
                           <a:solidFill>
                             <a:srgbClr val="FFFFFF"/>
                           </a:solidFill>
@@ -17637,7 +17939,7 @@
                         <a:spcAft>
                           <a:spcPts val="100"/>
                         </a:spcAft>
-                        <a:defRPr sz="1800" b="1">
+                        <a:defRPr sz="1550" b="1">
                           <a:solidFill>
                             <a:srgbClr val="FFFFFF"/>
                           </a:solidFill>
@@ -17667,7 +17969,7 @@
                         <a:spcAft>
                           <a:spcPts val="100"/>
                         </a:spcAft>
-                        <a:defRPr sz="1800" b="1">
+                        <a:defRPr sz="1550" b="1">
                           <a:solidFill>
                             <a:srgbClr val="FFFFFF"/>
                           </a:solidFill>
@@ -17686,7 +17988,7 @@
                   </a:tcPr>
                 </a:tc>
               </a:tr>
-              <a:tr h="822960">
+              <a:tr h="594360">
                 <a:tc>
                   <a:txBody>
                     <a:bodyPr wrap="square"/>
@@ -17699,7 +18001,56 @@
                         <a:spcAft>
                           <a:spcPts val="100"/>
                         </a:spcAft>
-                        <a:defRPr sz="1800" b="0">
+                        <a:defRPr sz="1550" b="0">
+                          <a:solidFill>
+                            <a:srgbClr val="17212B"/>
+                          </a:solidFill>
+                          <a:latin typeface="Arial"/>
+                        </a:defRPr>
+                      </a:pPr>
+                      <a:r>
+                        <a:t>Nguyễn Doãn Huy</a:t>
+                      </a:r>
+                    </a:p>
+                    <a:p>
+                      <a:pPr>
+                        <a:lnSpc>
+                          <a:spcPct val="102000"/>
+                        </a:lnSpc>
+                        <a:spcAft>
+                          <a:spcPts val="100"/>
+                        </a:spcAft>
+                        <a:defRPr sz="1550" b="0">
+                          <a:solidFill>
+                            <a:srgbClr val="17212B"/>
+                          </a:solidFill>
+                          <a:latin typeface="Arial"/>
+                        </a:defRPr>
+                      </a:pPr>
+                      <a:r>
+                        <a:t>MSSV: …………</a:t>
+                      </a:r>
+                    </a:p>
+                  </a:txBody>
+                  <a:tcPr marL="118872" marR="118872" marT="54864" marB="54864" anchor="ctr">
+                    <a:solidFill>
+                      <a:srgbClr val="FFFFFF"/>
+                    </a:solidFill>
+                  </a:tcPr>
+                </a:tc>
+                <a:tc>
+                  <a:txBody>
+                    <a:bodyPr wrap="square"/>
+                    <a:lstStyle/>
+                    <a:p>
+                      <a:pPr>
+                        <a:lnSpc>
+                          <a:spcPct val="102000"/>
+                        </a:lnSpc>
+                        <a:spcAft>
+                          <a:spcPts val="100"/>
+                        </a:spcAft>
+                        <a:defRPr sz="1550" b="0">
                           <a:solidFill>
                             <a:srgbClr val="17212B"/>
                           </a:solidFill>
@@ -17729,7 +18080,7 @@
                         <a:spcAft>
                           <a:spcPts val="100"/>
                         </a:spcAft>
-                        <a:defRPr sz="1800" b="0">
+                        <a:defRPr sz="1550" b="0">
                           <a:solidFill>
                             <a:srgbClr val="17212B"/>
                           </a:solidFill>
@@ -17737,7 +18088,7 @@
                         </a:defRPr>
                       </a:pPr>
                       <a:r>
-                        <a:t>………………………………</a:t>
+                        <a:t>…………</a:t>
                       </a:r>
                     </a:p>
                   </a:txBody>
@@ -17759,7 +18110,7 @@
                         <a:spcAft>
                           <a:spcPts val="100"/>
                         </a:spcAft>
-                        <a:defRPr sz="1800" b="0">
+                        <a:defRPr sz="1550" b="0">
                           <a:solidFill>
                             <a:srgbClr val="17212B"/>
                           </a:solidFill>
@@ -17767,7 +18118,58 @@
                         </a:defRPr>
                       </a:pPr>
                       <a:r>
-                        <a:t>Tài liệu / commit</a:t>
+                        <a:t>…… %</a:t>
+                      </a:r>
+                    </a:p>
+                  </a:txBody>
+                  <a:tcPr marL="118872" marR="118872" marT="54864" marB="54864" anchor="ctr">
+                    <a:solidFill>
+                      <a:srgbClr val="FFFFFF"/>
+                    </a:solidFill>
+                  </a:tcPr>
+                </a:tc>
+              </a:tr>
+              <a:tr h="594360">
+                <a:tc>
+                  <a:txBody>
+                    <a:bodyPr wrap="square"/>
+                    <a:lstStyle/>
+                    <a:p>
+                      <a:pPr>
+                        <a:lnSpc>
+                          <a:spcPct val="102000"/>
+                        </a:lnSpc>
+                        <a:spcAft>
+                          <a:spcPts val="100"/>
+                        </a:spcAft>
+                        <a:defRPr sz="1550" b="0">
+                          <a:solidFill>
+                            <a:srgbClr val="17212B"/>
+                          </a:solidFill>
+                          <a:latin typeface="Arial"/>
+                        </a:defRPr>
+                      </a:pPr>
+                      <a:r>
+                        <a:t>Phan Văn Hiếu</a:t>
+                      </a:r>
+                    </a:p>
+                    <a:p>
+                      <a:pPr>
+                        <a:lnSpc>
+                          <a:spcPct val="102000"/>
+                        </a:lnSpc>
+                        <a:spcAft>
+                          <a:spcPts val="100"/>
+                        </a:spcAft>
+                        <a:defRPr sz="1550" b="0">
+                          <a:solidFill>
+                            <a:srgbClr val="17212B"/>
+                          </a:solidFill>
+                          <a:latin typeface="Arial"/>
+                        </a:defRPr>
+                      </a:pPr>
+                      <a:r>
+                        <a:t>MSSV: …………</a:t>
                       </a:r>
                     </a:p>
                   </a:txBody>
@@ -17789,39 +18191,7 @@
                         <a:spcAft>
                           <a:spcPts val="100"/>
                         </a:spcAft>
-                        <a:defRPr sz="1800" b="0">
-                          <a:solidFill>
-                            <a:srgbClr val="17212B"/>
-                          </a:solidFill>
-                          <a:latin typeface="Arial"/>
-                        </a:defRPr>
-                      </a:pPr>
-                      <a:r>
-                        <a:t>…… %</a:t>
-                      </a:r>
-                    </a:p>
-                  </a:txBody>
-                  <a:tcPr marL="118872" marR="118872" marT="54864" marB="54864" anchor="ctr">
-                    <a:solidFill>
-                      <a:srgbClr val="FFFFFF"/>
-                    </a:solidFill>
-                  </a:tcPr>
-                </a:tc>
-              </a:tr>
-              <a:tr h="822960">
-                <a:tc>
-                  <a:txBody>
-                    <a:bodyPr wrap="square"/>
-                    <a:lstStyle/>
-                    <a:p>
-                      <a:pPr>
-                        <a:lnSpc>
-                          <a:spcPct val="102000"/>
-                        </a:lnSpc>
-                        <a:spcAft>
-                          <a:spcPts val="100"/>
-                        </a:spcAft>
-                        <a:defRPr sz="1800" b="0">
+                        <a:defRPr sz="1550" b="0">
                           <a:solidFill>
                             <a:srgbClr val="17212B"/>
                           </a:solidFill>
@@ -17851,7 +18221,7 @@
                         <a:spcAft>
                           <a:spcPts val="100"/>
                         </a:spcAft>
-                        <a:defRPr sz="1800" b="0">
+                        <a:defRPr sz="1550" b="0">
                           <a:solidFill>
                             <a:srgbClr val="17212B"/>
                           </a:solidFill>
@@ -17859,7 +18229,7 @@
                         </a:defRPr>
                       </a:pPr>
                       <a:r>
-                        <a:t>………………………………</a:t>
+                        <a:t>…………</a:t>
                       </a:r>
                     </a:p>
                   </a:txBody>
@@ -17881,7 +18251,7 @@
                         <a:spcAft>
                           <a:spcPts val="100"/>
                         </a:spcAft>
-                        <a:defRPr sz="1800" b="0">
+                        <a:defRPr sz="1550" b="0">
                           <a:solidFill>
                             <a:srgbClr val="17212B"/>
                           </a:solidFill>
@@ -17889,7 +18259,58 @@
                         </a:defRPr>
                       </a:pPr>
                       <a:r>
-                        <a:t>Tài liệu / commit</a:t>
+                        <a:t>…… %</a:t>
+                      </a:r>
+                    </a:p>
+                  </a:txBody>
+                  <a:tcPr marL="118872" marR="118872" marT="54864" marB="54864" anchor="ctr">
+                    <a:solidFill>
+                      <a:srgbClr val="FFFFFF"/>
+                    </a:solidFill>
+                  </a:tcPr>
+                </a:tc>
+              </a:tr>
+              <a:tr h="594360">
+                <a:tc>
+                  <a:txBody>
+                    <a:bodyPr wrap="square"/>
+                    <a:lstStyle/>
+                    <a:p>
+                      <a:pPr>
+                        <a:lnSpc>
+                          <a:spcPct val="102000"/>
+                        </a:lnSpc>
+                        <a:spcAft>
+                          <a:spcPts val="100"/>
+                        </a:spcAft>
+                        <a:defRPr sz="1550" b="0">
+                          <a:solidFill>
+                            <a:srgbClr val="17212B"/>
+                          </a:solidFill>
+                          <a:latin typeface="Arial"/>
+                        </a:defRPr>
+                      </a:pPr>
+                      <a:r>
+                        <a:t>Nguyễn Trần Tuấn Khôi</a:t>
+                      </a:r>
+                    </a:p>
+                    <a:p>
+                      <a:pPr>
+                        <a:lnSpc>
+                          <a:spcPct val="102000"/>
+                        </a:lnSpc>
+                        <a:spcAft>
+                          <a:spcPts val="100"/>
+                        </a:spcAft>
+                        <a:defRPr sz="1550" b="0">
+                          <a:solidFill>
+                            <a:srgbClr val="17212B"/>
+                          </a:solidFill>
+                          <a:latin typeface="Arial"/>
+                        </a:defRPr>
+                      </a:pPr>
+                      <a:r>
+                        <a:t>MSSV: …………</a:t>
                       </a:r>
                     </a:p>
                   </a:txBody>
@@ -17911,39 +18332,7 @@
                         <a:spcAft>
                           <a:spcPts val="100"/>
                         </a:spcAft>
-                        <a:defRPr sz="1800" b="0">
-                          <a:solidFill>
-                            <a:srgbClr val="17212B"/>
-                          </a:solidFill>
-                          <a:latin typeface="Arial"/>
-                        </a:defRPr>
-                      </a:pPr>
-                      <a:r>
-                        <a:t>…… %</a:t>
-                      </a:r>
-                    </a:p>
-                  </a:txBody>
-                  <a:tcPr marL="118872" marR="118872" marT="54864" marB="54864" anchor="ctr">
-                    <a:solidFill>
-                      <a:srgbClr val="FFFFFF"/>
-                    </a:solidFill>
-                  </a:tcPr>
-                </a:tc>
-              </a:tr>
-              <a:tr h="822960">
-                <a:tc>
-                  <a:txBody>
-                    <a:bodyPr wrap="square"/>
-                    <a:lstStyle/>
-                    <a:p>
-                      <a:pPr>
-                        <a:lnSpc>
-                          <a:spcPct val="102000"/>
-                        </a:lnSpc>
-                        <a:spcAft>
-                          <a:spcPts val="100"/>
-                        </a:spcAft>
-                        <a:defRPr sz="1800" b="0">
+                        <a:defRPr sz="1550" b="0">
                           <a:solidFill>
                             <a:srgbClr val="17212B"/>
                           </a:solidFill>
@@ -17973,7 +18362,7 @@
                         <a:spcAft>
                           <a:spcPts val="100"/>
                         </a:spcAft>
-                        <a:defRPr sz="1800" b="0">
+                        <a:defRPr sz="1550" b="0">
                           <a:solidFill>
                             <a:srgbClr val="17212B"/>
                           </a:solidFill>
@@ -17981,7 +18370,7 @@
                         </a:defRPr>
                       </a:pPr>
                       <a:r>
-                        <a:t>………………………………</a:t>
+                        <a:t>…………</a:t>
                       </a:r>
                     </a:p>
                   </a:txBody>
@@ -18003,7 +18392,7 @@
                         <a:spcAft>
                           <a:spcPts val="100"/>
                         </a:spcAft>
-                        <a:defRPr sz="1800" b="0">
+                        <a:defRPr sz="1550" b="0">
                           <a:solidFill>
                             <a:srgbClr val="17212B"/>
                           </a:solidFill>
@@ -18011,7 +18400,58 @@
                         </a:defRPr>
                       </a:pPr>
                       <a:r>
-                        <a:t>Tài liệu / commit</a:t>
+                        <a:t>…… %</a:t>
+                      </a:r>
+                    </a:p>
+                  </a:txBody>
+                  <a:tcPr marL="118872" marR="118872" marT="54864" marB="54864" anchor="ctr">
+                    <a:solidFill>
+                      <a:srgbClr val="FFFFFF"/>
+                    </a:solidFill>
+                  </a:tcPr>
+                </a:tc>
+              </a:tr>
+              <a:tr h="594360">
+                <a:tc>
+                  <a:txBody>
+                    <a:bodyPr wrap="square"/>
+                    <a:lstStyle/>
+                    <a:p>
+                      <a:pPr>
+                        <a:lnSpc>
+                          <a:spcPct val="102000"/>
+                        </a:lnSpc>
+                        <a:spcAft>
+                          <a:spcPts val="100"/>
+                        </a:spcAft>
+                        <a:defRPr sz="1550" b="0">
+                          <a:solidFill>
+                            <a:srgbClr val="17212B"/>
+                          </a:solidFill>
+                          <a:latin typeface="Arial"/>
+                        </a:defRPr>
+                      </a:pPr>
+                      <a:r>
+                        <a:t>Nie Phương Anh</a:t>
+                      </a:r>
+                    </a:p>
+                    <a:p>
+                      <a:pPr>
+                        <a:lnSpc>
+                          <a:spcPct val="102000"/>
+                        </a:lnSpc>
+                        <a:spcAft>
+                          <a:spcPts val="100"/>
+                        </a:spcAft>
+                        <a:defRPr sz="1550" b="0">
+                          <a:solidFill>
+                            <a:srgbClr val="17212B"/>
+                          </a:solidFill>
+                          <a:latin typeface="Arial"/>
+                        </a:defRPr>
+                      </a:pPr>
+                      <a:r>
+                        <a:t>MSSV: …………</a:t>
                       </a:r>
                     </a:p>
                   </a:txBody>
@@ -18033,39 +18473,7 @@
                         <a:spcAft>
                           <a:spcPts val="100"/>
                         </a:spcAft>
-                        <a:defRPr sz="1800" b="0">
-                          <a:solidFill>
-                            <a:srgbClr val="17212B"/>
-                          </a:solidFill>
-                          <a:latin typeface="Arial"/>
-                        </a:defRPr>
-                      </a:pPr>
-                      <a:r>
-                        <a:t>…… %</a:t>
-                      </a:r>
-                    </a:p>
-                  </a:txBody>
-                  <a:tcPr marL="118872" marR="118872" marT="54864" marB="54864" anchor="ctr">
-                    <a:solidFill>
-                      <a:srgbClr val="FFFFFF"/>
-                    </a:solidFill>
-                  </a:tcPr>
-                </a:tc>
-              </a:tr>
-              <a:tr h="822960">
-                <a:tc>
-                  <a:txBody>
-                    <a:bodyPr wrap="square"/>
-                    <a:lstStyle/>
-                    <a:p>
-                      <a:pPr>
-                        <a:lnSpc>
-                          <a:spcPct val="102000"/>
-                        </a:lnSpc>
-                        <a:spcAft>
-                          <a:spcPts val="100"/>
-                        </a:spcAft>
-                        <a:defRPr sz="1800" b="0">
+                        <a:defRPr sz="1550" b="0">
                           <a:solidFill>
                             <a:srgbClr val="17212B"/>
                           </a:solidFill>
@@ -18095,7 +18503,7 @@
                         <a:spcAft>
                           <a:spcPts val="100"/>
                         </a:spcAft>
-                        <a:defRPr sz="1800" b="0">
+                        <a:defRPr sz="1550" b="0">
                           <a:solidFill>
                             <a:srgbClr val="17212B"/>
                           </a:solidFill>
@@ -18103,7 +18511,7 @@
                         </a:defRPr>
                       </a:pPr>
                       <a:r>
-                        <a:t>………………………………</a:t>
+                        <a:t>…………</a:t>
                       </a:r>
                     </a:p>
                   </a:txBody>
@@ -18125,7 +18533,7 @@
                         <a:spcAft>
                           <a:spcPts val="100"/>
                         </a:spcAft>
-                        <a:defRPr sz="1800" b="0">
+                        <a:defRPr sz="1550" b="0">
                           <a:solidFill>
                             <a:srgbClr val="17212B"/>
                           </a:solidFill>
@@ -18133,7 +18541,58 @@
                         </a:defRPr>
                       </a:pPr>
                       <a:r>
-                        <a:t>Tài liệu / commit</a:t>
+                        <a:t>…… %</a:t>
+                      </a:r>
+                    </a:p>
+                  </a:txBody>
+                  <a:tcPr marL="118872" marR="118872" marT="54864" marB="54864" anchor="ctr">
+                    <a:solidFill>
+                      <a:srgbClr val="FFFFFF"/>
+                    </a:solidFill>
+                  </a:tcPr>
+                </a:tc>
+              </a:tr>
+              <a:tr h="594360">
+                <a:tc>
+                  <a:txBody>
+                    <a:bodyPr wrap="square"/>
+                    <a:lstStyle/>
+                    <a:p>
+                      <a:pPr>
+                        <a:lnSpc>
+                          <a:spcPct val="102000"/>
+                        </a:lnSpc>
+                        <a:spcAft>
+                          <a:spcPts val="100"/>
+                        </a:spcAft>
+                        <a:defRPr sz="1550" b="0">
+                          <a:solidFill>
+                            <a:srgbClr val="17212B"/>
+                          </a:solidFill>
+                          <a:latin typeface="Arial"/>
+                        </a:defRPr>
+                      </a:pPr>
+                      <a:r>
+                        <a:t>Trần Đức Nguyên</a:t>
+                      </a:r>
+                    </a:p>
+                    <a:p>
+                      <a:pPr>
+                        <a:lnSpc>
+                          <a:spcPct val="102000"/>
+                        </a:lnSpc>
+                        <a:spcAft>
+                          <a:spcPts val="100"/>
+                        </a:spcAft>
+                        <a:defRPr sz="1550" b="0">
+                          <a:solidFill>
+                            <a:srgbClr val="17212B"/>
+                          </a:solidFill>
+                          <a:latin typeface="Arial"/>
+                        </a:defRPr>
+                      </a:pPr>
+                      <a:r>
+                        <a:t>MSSV: …………</a:t>
                       </a:r>
                     </a:p>
                   </a:txBody>
@@ -18155,7 +18614,208 @@
                         <a:spcAft>
                           <a:spcPts val="100"/>
                         </a:spcAft>
-                        <a:defRPr sz="1800" b="0">
+                        <a:defRPr sz="1550" b="0">
+                          <a:solidFill>
+                            <a:srgbClr val="17212B"/>
+                          </a:solidFill>
+                          <a:latin typeface="Arial"/>
+                        </a:defRPr>
+                      </a:pPr>
+                      <a:r>
+                        <a:t>……………………</a:t>
+                      </a:r>
+                    </a:p>
+                  </a:txBody>
+                  <a:tcPr marL="118872" marR="118872" marT="54864" marB="54864" anchor="ctr">
+                    <a:solidFill>
+                      <a:srgbClr val="FFFFFF"/>
+                    </a:solidFill>
+                  </a:tcPr>
+                </a:tc>
+                <a:tc>
+                  <a:txBody>
+                    <a:bodyPr wrap="square"/>
+                    <a:lstStyle/>
+                    <a:p>
+                      <a:pPr>
+                        <a:lnSpc>
+                          <a:spcPct val="102000"/>
+                        </a:lnSpc>
+                        <a:spcAft>
+                          <a:spcPts val="100"/>
+                        </a:spcAft>
+                        <a:defRPr sz="1550" b="0">
+                          <a:solidFill>
+                            <a:srgbClr val="17212B"/>
+                          </a:solidFill>
+                          <a:latin typeface="Arial"/>
+                        </a:defRPr>
+                      </a:pPr>
+                      <a:r>
+                        <a:t>…………</a:t>
+                      </a:r>
+                    </a:p>
+                  </a:txBody>
+                  <a:tcPr marL="118872" marR="118872" marT="54864" marB="54864" anchor="ctr">
+                    <a:solidFill>
+                      <a:srgbClr val="FFFFFF"/>
+                    </a:solidFill>
+                  </a:tcPr>
+                </a:tc>
+                <a:tc>
+                  <a:txBody>
+                    <a:bodyPr wrap="square"/>
+                    <a:lstStyle/>
+                    <a:p>
+                      <a:pPr>
+                        <a:lnSpc>
+                          <a:spcPct val="102000"/>
+                        </a:lnSpc>
+                        <a:spcAft>
+                          <a:spcPts val="100"/>
+                        </a:spcAft>
+                        <a:defRPr sz="1550" b="0">
+                          <a:solidFill>
+                            <a:srgbClr val="17212B"/>
+                          </a:solidFill>
+                          <a:latin typeface="Arial"/>
+                        </a:defRPr>
+                      </a:pPr>
+                      <a:r>
+                        <a:t>…… %</a:t>
+                      </a:r>
+                    </a:p>
+                  </a:txBody>
+                  <a:tcPr marL="118872" marR="118872" marT="54864" marB="54864" anchor="ctr">
+                    <a:solidFill>
+                      <a:srgbClr val="FFFFFF"/>
+                    </a:solidFill>
+                  </a:tcPr>
+                </a:tc>
+              </a:tr>
+              <a:tr h="594360">
+                <a:tc>
+                  <a:txBody>
+                    <a:bodyPr wrap="square"/>
+                    <a:lstStyle/>
+                    <a:p>
+                      <a:pPr>
+                        <a:lnSpc>
+                          <a:spcPct val="102000"/>
+                        </a:lnSpc>
+                        <a:spcAft>
+                          <a:spcPts val="100"/>
+                        </a:spcAft>
+                        <a:defRPr sz="1550" b="0">
+                          <a:solidFill>
+                            <a:srgbClr val="17212B"/>
+                          </a:solidFill>
+                          <a:latin typeface="Arial"/>
+                        </a:defRPr>
+                      </a:pPr>
+                      <a:r>
+                        <a:t>Nguyễn Quang Trung</a:t>
+                      </a:r>
+                    </a:p>
+                    <a:p>
+                      <a:pPr>
+                        <a:lnSpc>
+                          <a:spcPct val="102000"/>
+                        </a:lnSpc>
+                        <a:spcAft>
+                          <a:spcPts val="100"/>
+                        </a:spcAft>
+                        <a:defRPr sz="1550" b="0">
+                          <a:solidFill>
+                            <a:srgbClr val="17212B"/>
+                          </a:solidFill>
+                          <a:latin typeface="Arial"/>
+                        </a:defRPr>
+                      </a:pPr>
+                      <a:r>
+                        <a:t>MSSV: …………</a:t>
+                      </a:r>
+                    </a:p>
+                  </a:txBody>
+                  <a:tcPr marL="118872" marR="118872" marT="54864" marB="54864" anchor="ctr">
+                    <a:solidFill>
+                      <a:srgbClr val="FFFFFF"/>
+                    </a:solidFill>
+                  </a:tcPr>
+                </a:tc>
+                <a:tc>
+                  <a:txBody>
+                    <a:bodyPr wrap="square"/>
+                    <a:lstStyle/>
+                    <a:p>
+                      <a:pPr>
+                        <a:lnSpc>
+                          <a:spcPct val="102000"/>
+                        </a:lnSpc>
+                        <a:spcAft>
+                          <a:spcPts val="100"/>
+                        </a:spcAft>
+                        <a:defRPr sz="1550" b="0">
+                          <a:solidFill>
+                            <a:srgbClr val="17212B"/>
+                          </a:solidFill>
+                          <a:latin typeface="Arial"/>
+                        </a:defRPr>
+                      </a:pPr>
+                      <a:r>
+                        <a:t>……………………</a:t>
+                      </a:r>
+                    </a:p>
+                  </a:txBody>
+                  <a:tcPr marL="118872" marR="118872" marT="54864" marB="54864" anchor="ctr">
+                    <a:solidFill>
+                      <a:srgbClr val="FFFFFF"/>
+                    </a:solidFill>
+                  </a:tcPr>
+                </a:tc>
+                <a:tc>
+                  <a:txBody>
+                    <a:bodyPr wrap="square"/>
+                    <a:lstStyle/>
+                    <a:p>
+                      <a:pPr>
+                        <a:lnSpc>
+                          <a:spcPct val="102000"/>
+                        </a:lnSpc>
+                        <a:spcAft>
+                          <a:spcPts val="100"/>
+                        </a:spcAft>
+                        <a:defRPr sz="1550" b="0">
+                          <a:solidFill>
+                            <a:srgbClr val="17212B"/>
+                          </a:solidFill>
+                          <a:latin typeface="Arial"/>
+                        </a:defRPr>
+                      </a:pPr>
+                      <a:r>
+                        <a:t>…………</a:t>
+                      </a:r>
+                    </a:p>
+                  </a:txBody>
+                  <a:tcPr marL="118872" marR="118872" marT="54864" marB="54864" anchor="ctr">
+                    <a:solidFill>
+                      <a:srgbClr val="FFFFFF"/>
+                    </a:solidFill>
+                  </a:tcPr>
+                </a:tc>
+                <a:tc>
+                  <a:txBody>
+                    <a:bodyPr wrap="square"/>
+                    <a:lstStyle/>
+                    <a:p>
+                      <a:pPr>
+                        <a:lnSpc>
+                          <a:spcPct val="102000"/>
+                        </a:lnSpc>
+                        <a:spcAft>
+                          <a:spcPts val="100"/>
+                        </a:spcAft>
+                        <a:defRPr sz="1550" b="0">
                           <a:solidFill>
                             <a:srgbClr val="17212B"/>
                           </a:solidFill>
@@ -18207,7 +18867,7 @@
               <a:spcAft>
                 <a:spcPts val="0"/>
               </a:spcAft>
-              <a:defRPr sz="1900" b="1">
+              <a:defRPr sz="1800" b="1">
                 <a:solidFill>
                   <a:srgbClr val="17212B"/>
                 </a:solidFill>
@@ -18215,7 +18875,7 @@
               </a:defRPr>
             </a:pPr>
             <a:r>
-              <a:t>Tổng tỷ lệ đóng góp: 100%.</a:t>
+              <a:t>Tổng tỷ lệ đóng góp: …… / 100%.</a:t>
             </a:r>
           </a:p>
         </p:txBody>
@@ -20489,13 +21149,16 @@
               </a:spcAft>
               <a:defRPr sz="1300" b="0">
                 <a:solidFill>
-                  <a:srgbClr val="59636E"/>
+                  <a:srgbClr val="284A63"/>
                 </a:solidFill>
                 <a:latin typeface="Arial"/>
               </a:defRPr>
             </a:pPr>
             <a:r>
-              <a:t>17 bảng • 28 khóa ngoại • Bản xuất từ dbdiagram.io</a:t>
+              <a:rPr>
+                <a:hlinkClick r:id="rId3"/>
+              </a:rPr>
+              <a:t>Xem đầy đủ và phóng to: dbdiagram.io — Quản lý nhà trọ</a:t>
             </a:r>
           </a:p>
         </p:txBody>
@@ -21173,7 +21836,7 @@
                         </a:defRPr>
                       </a:pPr>
                       <a:r>
-                        <a:t>Xem hợp đồng, hóa đơn, giao dịch; gửi và theo dõi sự cố</a:t>
+                        <a:t>Xem hợp đồng, hóa đơn đã phát hành, giao dịch; gửi và theo dõi sự cố</a:t>
                       </a:r>
                     </a:p>
                   </a:txBody>
@@ -21876,7 +22539,7 @@
                         </a:defRPr>
                       </a:pPr>
                       <a:r>
-                        <a:t>Tạo khu/phòng; cập nhật phòng; chuyển phòng bảo trì</a:t>
+                        <a:t>Tạo, cập nhật khu/phòng; ngừng khu; xóa phòng chưa có phụ thuộc</a:t>
                       </a:r>
                     </a:p>
                   </a:txBody>
@@ -21906,7 +22569,7 @@
                         </a:defRPr>
                       </a:pPr>
                       <a:r>
-                        <a:t>ADMIN; STAFF theo quyền</a:t>
+                        <a:t>ADMIN; STAFF chỉ sửa phòng trong khu được giao</a:t>
                       </a:r>
                     </a:p>
                   </a:txBody>
@@ -21998,7 +22661,7 @@
                         </a:defRPr>
                       </a:pPr>
                       <a:r>
-                        <a:t>ADMIN; tra cứu có giới hạn</a:t>
+                        <a:t>ADMIN tạo/sửa; STAFF/TENANT xem theo phạm vi</a:t>
                       </a:r>
                     </a:p>
                   </a:txBody>
@@ -22381,7 +23044,7 @@
         </p:nvGraphicFramePr>
         <p:xfrm>
           <a:off x="594360" y="1600200"/>
-          <a:ext cx="10972800" cy="4224528"/>
+          <a:ext cx="10972800" cy="4544568"/>
         </p:xfrm>
         <a:graphic>
           <a:graphicData uri="http://schemas.openxmlformats.org/drawingml/2006/table">
@@ -22390,10 +23053,11 @@
                 <a:tableStyleId>{5C22544A-7EE6-4342-B048-85BDC9FD1C3A}</a:tableStyleId>
               </a:tblPr>
               <a:tblGrid>
-                <a:gridCol w="2011680"/>
-                <a:gridCol w="8961120"/>
+                <a:gridCol w="1554480"/>
+                <a:gridCol w="6583680"/>
+                <a:gridCol w="2834640"/>
               </a:tblGrid>
-              <a:tr h="603504">
+              <a:tr h="649224">
                 <a:tc>
                   <a:txBody>
                     <a:bodyPr wrap="square"/>
@@ -22406,7 +23070,7 @@
                         <a:spcAft>
                           <a:spcPts val="100"/>
                         </a:spcAft>
-                        <a:defRPr sz="1800" b="1">
+                        <a:defRPr sz="1700" b="1">
                           <a:solidFill>
                             <a:srgbClr val="FFFFFF"/>
                           </a:solidFill>
@@ -22436,7 +23100,7 @@
                         <a:spcAft>
                           <a:spcPts val="100"/>
                         </a:spcAft>
-                        <a:defRPr sz="1800" b="1">
+                        <a:defRPr sz="1700" b="1">
                           <a:solidFill>
                             <a:srgbClr val="FFFFFF"/>
                           </a:solidFill>
@@ -22454,8 +23118,6 @@
                     </a:solidFill>
                   </a:tcPr>
                 </a:tc>
-              </a:tr>
-              <a:tr h="603504">
                 <a:tc>
                   <a:txBody>
                     <a:bodyPr wrap="square"/>
@@ -22468,7 +23130,39 @@
                         <a:spcAft>
                           <a:spcPts val="100"/>
                         </a:spcAft>
-                        <a:defRPr sz="1800" b="0">
+                        <a:defRPr sz="1700" b="1">
+                          <a:solidFill>
+                            <a:srgbClr val="FFFFFF"/>
+                          </a:solidFill>
+                          <a:latin typeface="Arial"/>
+                        </a:defRPr>
+                      </a:pPr>
+                      <a:r>
+                        <a:t>Tác nhân</a:t>
+                      </a:r>
+                    </a:p>
+                  </a:txBody>
+                  <a:tcPr marL="118872" marR="118872" marT="54864" marB="54864" anchor="ctr">
+                    <a:solidFill>
+                      <a:srgbClr val="284A63"/>
+                    </a:solidFill>
+                  </a:tcPr>
+                </a:tc>
+              </a:tr>
+              <a:tr h="649224">
+                <a:tc>
+                  <a:txBody>
+                    <a:bodyPr wrap="square"/>
+                    <a:lstStyle/>
+                    <a:p>
+                      <a:pPr>
+                        <a:lnSpc>
+                          <a:spcPct val="102000"/>
+                        </a:lnSpc>
+                        <a:spcAft>
+                          <a:spcPts val="100"/>
+                        </a:spcAft>
+                        <a:defRPr sz="1700" b="0">
                           <a:solidFill>
                             <a:srgbClr val="17212B"/>
                           </a:solidFill>
@@ -22498,7 +23192,7 @@
                         <a:spcAft>
                           <a:spcPts val="100"/>
                         </a:spcAft>
-                        <a:defRPr sz="1800" b="0">
+                        <a:defRPr sz="1700" b="0">
                           <a:solidFill>
                             <a:srgbClr val="17212B"/>
                           </a:solidFill>
@@ -22516,8 +23210,6 @@
                     </a:solidFill>
                   </a:tcPr>
                 </a:tc>
-              </a:tr>
-              <a:tr h="603504">
                 <a:tc>
                   <a:txBody>
                     <a:bodyPr wrap="square"/>
@@ -22530,7 +23222,39 @@
                         <a:spcAft>
                           <a:spcPts val="100"/>
                         </a:spcAft>
-                        <a:defRPr sz="1800" b="0">
+                        <a:defRPr sz="1700" b="0">
+                          <a:solidFill>
+                            <a:srgbClr val="17212B"/>
+                          </a:solidFill>
+                          <a:latin typeface="Arial"/>
+                        </a:defRPr>
+                      </a:pPr>
+                      <a:r>
+                        <a:t>ADMIN</a:t>
+                      </a:r>
+                    </a:p>
+                  </a:txBody>
+                  <a:tcPr marL="118872" marR="118872" marT="54864" marB="54864" anchor="ctr">
+                    <a:solidFill>
+                      <a:srgbClr val="FFFFFF"/>
+                    </a:solidFill>
+                  </a:tcPr>
+                </a:tc>
+              </a:tr>
+              <a:tr h="649224">
+                <a:tc>
+                  <a:txBody>
+                    <a:bodyPr wrap="square"/>
+                    <a:lstStyle/>
+                    <a:p>
+                      <a:pPr>
+                        <a:lnSpc>
+                          <a:spcPct val="102000"/>
+                        </a:lnSpc>
+                        <a:spcAft>
+                          <a:spcPts val="100"/>
+                        </a:spcAft>
+                        <a:defRPr sz="1700" b="0">
                           <a:solidFill>
                             <a:srgbClr val="17212B"/>
                           </a:solidFill>
@@ -22560,7 +23284,7 @@
                         <a:spcAft>
                           <a:spcPts val="100"/>
                         </a:spcAft>
-                        <a:defRPr sz="1800" b="0">
+                        <a:defRPr sz="1700" b="0">
                           <a:solidFill>
                             <a:srgbClr val="17212B"/>
                           </a:solidFill>
@@ -22568,7 +23292,7 @@
                         </a:defRPr>
                       </a:pPr>
                       <a:r>
-                        <a:t>Ghi chỉ số; sửa chỉ số cuối; kiểm tra cảnh báo</a:t>
+                        <a:t>Ghi/sửa chỉ số cuối; kiểm tra cảnh báo</a:t>
                       </a:r>
                     </a:p>
                   </a:txBody>
@@ -22578,8 +23302,6 @@
                     </a:solidFill>
                   </a:tcPr>
                 </a:tc>
-              </a:tr>
-              <a:tr h="603504">
                 <a:tc>
                   <a:txBody>
                     <a:bodyPr wrap="square"/>
@@ -22592,7 +23314,39 @@
                         <a:spcAft>
                           <a:spcPts val="100"/>
                         </a:spcAft>
-                        <a:defRPr sz="1800" b="0">
+                        <a:defRPr sz="1700" b="0">
+                          <a:solidFill>
+                            <a:srgbClr val="17212B"/>
+                          </a:solidFill>
+                          <a:latin typeface="Arial"/>
+                        </a:defRPr>
+                      </a:pPr>
+                      <a:r>
+                        <a:t>ADMIN / STAFF</a:t>
+                      </a:r>
+                    </a:p>
+                  </a:txBody>
+                  <a:tcPr marL="118872" marR="118872" marT="54864" marB="54864" anchor="ctr">
+                    <a:solidFill>
+                      <a:srgbClr val="FFFFFF"/>
+                    </a:solidFill>
+                  </a:tcPr>
+                </a:tc>
+              </a:tr>
+              <a:tr h="649224">
+                <a:tc>
+                  <a:txBody>
+                    <a:bodyPr wrap="square"/>
+                    <a:lstStyle/>
+                    <a:p>
+                      <a:pPr>
+                        <a:lnSpc>
+                          <a:spcPct val="102000"/>
+                        </a:lnSpc>
+                        <a:spcAft>
+                          <a:spcPts val="100"/>
+                        </a:spcAft>
+                        <a:defRPr sz="1700" b="0">
                           <a:solidFill>
                             <a:srgbClr val="17212B"/>
                           </a:solidFill>
@@ -22622,7 +23376,7 @@
                         <a:spcAft>
                           <a:spcPts val="100"/>
                         </a:spcAft>
-                        <a:defRPr sz="1800" b="0">
+                        <a:defRPr sz="1700" b="0">
                           <a:solidFill>
                             <a:srgbClr val="17212B"/>
                           </a:solidFill>
@@ -22630,7 +23384,7 @@
                         </a:defRPr>
                       </a:pPr>
                       <a:r>
-                        <a:t>Lập nháp; xóa nháp; phát hành; tra cứu hóa đơn</a:t>
+                        <a:t>Lập/xóa nháp; phát hành; tra cứu hóa đơn</a:t>
                       </a:r>
                     </a:p>
                   </a:txBody>
@@ -22640,8 +23394,6 @@
                     </a:solidFill>
                   </a:tcPr>
                 </a:tc>
-              </a:tr>
-              <a:tr h="603504">
                 <a:tc>
                   <a:txBody>
                     <a:bodyPr wrap="square"/>
@@ -22654,7 +23406,39 @@
                         <a:spcAft>
                           <a:spcPts val="100"/>
                         </a:spcAft>
-                        <a:defRPr sz="1800" b="0">
+                        <a:defRPr sz="1700" b="0">
+                          <a:solidFill>
+                            <a:srgbClr val="17212B"/>
+                          </a:solidFill>
+                          <a:latin typeface="Arial"/>
+                        </a:defRPr>
+                      </a:pPr>
+                      <a:r>
+                        <a:t>ADMIN / STAFF; TENANT xem bản phát hành</a:t>
+                      </a:r>
+                    </a:p>
+                  </a:txBody>
+                  <a:tcPr marL="118872" marR="118872" marT="54864" marB="54864" anchor="ctr">
+                    <a:solidFill>
+                      <a:srgbClr val="FFFFFF"/>
+                    </a:solidFill>
+                  </a:tcPr>
+                </a:tc>
+              </a:tr>
+              <a:tr h="649224">
+                <a:tc>
+                  <a:txBody>
+                    <a:bodyPr wrap="square"/>
+                    <a:lstStyle/>
+                    <a:p>
+                      <a:pPr>
+                        <a:lnSpc>
+                          <a:spcPct val="102000"/>
+                        </a:lnSpc>
+                        <a:spcAft>
+                          <a:spcPts val="100"/>
+                        </a:spcAft>
+                        <a:defRPr sz="1700" b="0">
                           <a:solidFill>
                             <a:srgbClr val="17212B"/>
                           </a:solidFill>
@@ -22684,7 +23468,7 @@
                         <a:spcAft>
                           <a:spcPts val="100"/>
                         </a:spcAft>
-                        <a:defRPr sz="1800" b="0">
+                        <a:defRPr sz="1700" b="0">
                           <a:solidFill>
                             <a:srgbClr val="17212B"/>
                           </a:solidFill>
@@ -22692,7 +23476,7 @@
                         </a:defRPr>
                       </a:pPr>
                       <a:r>
-                        <a:t>Ghi nhận thanh toán; tra cứu công nợ; tổng hợp tiền thu</a:t>
+                        <a:t>Ghi nhận thanh toán; tra cứu công nợ; tổng hợp thu</a:t>
                       </a:r>
                     </a:p>
                   </a:txBody>
@@ -22702,8 +23486,6 @@
                     </a:solidFill>
                   </a:tcPr>
                 </a:tc>
-              </a:tr>
-              <a:tr h="603504">
                 <a:tc>
                   <a:txBody>
                     <a:bodyPr wrap="square"/>
@@ -22716,7 +23498,39 @@
                         <a:spcAft>
                           <a:spcPts val="100"/>
                         </a:spcAft>
-                        <a:defRPr sz="1800" b="0">
+                        <a:defRPr sz="1700" b="0">
+                          <a:solidFill>
+                            <a:srgbClr val="17212B"/>
+                          </a:solidFill>
+                          <a:latin typeface="Arial"/>
+                        </a:defRPr>
+                      </a:pPr>
+                      <a:r>
+                        <a:t>ADMIN / STAFF; TENANT xem của mình</a:t>
+                      </a:r>
+                    </a:p>
+                  </a:txBody>
+                  <a:tcPr marL="118872" marR="118872" marT="54864" marB="54864" anchor="ctr">
+                    <a:solidFill>
+                      <a:srgbClr val="FFFFFF"/>
+                    </a:solidFill>
+                  </a:tcPr>
+                </a:tc>
+              </a:tr>
+              <a:tr h="649224">
+                <a:tc>
+                  <a:txBody>
+                    <a:bodyPr wrap="square"/>
+                    <a:lstStyle/>
+                    <a:p>
+                      <a:pPr>
+                        <a:lnSpc>
+                          <a:spcPct val="102000"/>
+                        </a:lnSpc>
+                        <a:spcAft>
+                          <a:spcPts val="100"/>
+                        </a:spcAft>
+                        <a:defRPr sz="1700" b="0">
                           <a:solidFill>
                             <a:srgbClr val="17212B"/>
                           </a:solidFill>
@@ -22746,7 +23560,7 @@
                         <a:spcAft>
                           <a:spcPts val="100"/>
                         </a:spcAft>
-                        <a:defRPr sz="1800" b="0">
+                        <a:defRPr sz="1700" b="0">
                           <a:solidFill>
                             <a:srgbClr val="17212B"/>
                           </a:solidFill>
@@ -22764,8 +23578,6 @@
                     </a:solidFill>
                   </a:tcPr>
                 </a:tc>
-              </a:tr>
-              <a:tr h="603504">
                 <a:tc>
                   <a:txBody>
                     <a:bodyPr wrap="square"/>
@@ -22778,7 +23590,39 @@
                         <a:spcAft>
                           <a:spcPts val="100"/>
                         </a:spcAft>
-                        <a:defRPr sz="1800" b="0">
+                        <a:defRPr sz="1700" b="0">
+                          <a:solidFill>
+                            <a:srgbClr val="17212B"/>
+                          </a:solidFill>
+                          <a:latin typeface="Arial"/>
+                        </a:defRPr>
+                      </a:pPr>
+                      <a:r>
+                        <a:t>ADMIN / STAFF</a:t>
+                      </a:r>
+                    </a:p>
+                  </a:txBody>
+                  <a:tcPr marL="118872" marR="118872" marT="54864" marB="54864" anchor="ctr">
+                    <a:solidFill>
+                      <a:srgbClr val="FFFFFF"/>
+                    </a:solidFill>
+                  </a:tcPr>
+                </a:tc>
+              </a:tr>
+              <a:tr h="649224">
+                <a:tc>
+                  <a:txBody>
+                    <a:bodyPr wrap="square"/>
+                    <a:lstStyle/>
+                    <a:p>
+                      <a:pPr>
+                        <a:lnSpc>
+                          <a:spcPct val="102000"/>
+                        </a:lnSpc>
+                        <a:spcAft>
+                          <a:spcPts val="100"/>
+                        </a:spcAft>
+                        <a:defRPr sz="1700" b="0">
                           <a:solidFill>
                             <a:srgbClr val="17212B"/>
                           </a:solidFill>
@@ -22808,7 +23652,7 @@
                         <a:spcAft>
                           <a:spcPts val="100"/>
                         </a:spcAft>
-                        <a:defRPr sz="1800" b="0">
+                        <a:defRPr sz="1700" b="0">
                           <a:solidFill>
                             <a:srgbClr val="17212B"/>
                           </a:solidFill>
@@ -22816,7 +23660,37 @@
                         </a:defRPr>
                       </a:pPr>
                       <a:r>
-                        <a:t>Gửi yêu cầu; đính kèm ảnh; cập nhật và theo dõi tiến độ</a:t>
+                        <a:t>Gửi yêu cầu; đính kèm ảnh; cập nhật, theo dõi tiến độ</a:t>
+                      </a:r>
+                    </a:p>
+                  </a:txBody>
+                  <a:tcPr marL="118872" marR="118872" marT="54864" marB="54864" anchor="ctr">
+                    <a:solidFill>
+                      <a:srgbClr val="FFFFFF"/>
+                    </a:solidFill>
+                  </a:tcPr>
+                </a:tc>
+                <a:tc>
+                  <a:txBody>
+                    <a:bodyPr wrap="square"/>
+                    <a:lstStyle/>
+                    <a:p>
+                      <a:pPr>
+                        <a:lnSpc>
+                          <a:spcPct val="102000"/>
+                        </a:lnSpc>
+                        <a:spcAft>
+                          <a:spcPts val="100"/>
+                        </a:spcAft>
+                        <a:defRPr sz="1700" b="0">
+                          <a:solidFill>
+                            <a:srgbClr val="17212B"/>
+                          </a:solidFill>
+                          <a:latin typeface="Arial"/>
+                        </a:defRPr>
+                      </a:pPr>
+                      <a:r>
+                        <a:t>TENANT gửi; ADMIN / STAFF xử lý</a:t>
                       </a:r>
                     </a:p>
                   </a:txBody>
@@ -24027,7 +24901,7 @@
               <a:spcAft>
                 <a:spcPts val="500"/>
               </a:spcAft>
-              <a:defRPr sz="1600" b="0">
+              <a:defRPr sz="1500" b="0">
                 <a:solidFill>
                   <a:srgbClr val="17212B"/>
                 </a:solidFill>
@@ -24035,7 +24909,26 @@
               </a:defRPr>
             </a:pPr>
             <a:r>
-              <a:t>Quản lý kiểm tra</a:t>
+              <a:t>Kiểm tra các cảnh báo</a:t>
+            </a:r>
+          </a:p>
+          <a:p>
+            <a:pPr algn="ctr">
+              <a:lnSpc>
+                <a:spcPct val="108000"/>
+              </a:lnSpc>
+              <a:spcAft>
+                <a:spcPts val="500"/>
+              </a:spcAft>
+              <a:defRPr sz="1500" b="0">
+                <a:solidFill>
+                  <a:srgbClr val="17212B"/>
+                </a:solidFill>
+                <a:latin typeface="Arial"/>
+              </a:defRPr>
+            </a:pPr>
+            <a:r>
+              <a:t>Đúng: xác nhận hết</a:t>
             </a:r>
           </a:p>
           <a:p>
@@ -24046,7 +24939,7 @@
               <a:spcAft>
                 <a:spcPts val="0"/>
               </a:spcAft>
-              <a:defRPr sz="1600" b="0">
+              <a:defRPr sz="1500" b="0">
                 <a:solidFill>
                   <a:srgbClr val="17212B"/>
                 </a:solidFill>
@@ -24054,7 +24947,7 @@
               </a:defRPr>
             </a:pPr>
             <a:r>
-              <a:t>Xác nhận / sửa chỉ số</a:t>
+              <a:t>Sai: xóa nháp, sửa số</a:t>
             </a:r>
           </a:p>
         </p:txBody>
@@ -26074,6 +26967,310 @@
               <a:spcAft>
                 <a:spcPts val="500"/>
               </a:spcAft>
+              <a:defRPr sz="1500" b="0">
+                <a:solidFill>
+                  <a:srgbClr val="17212B"/>
+                </a:solidFill>
+                <a:latin typeface="Arial"/>
+              </a:defRPr>
+            </a:pPr>
+            <a:r>
+              <a:t>Đủ hóa đơn ISSUED,</a:t>
+            </a:r>
+          </a:p>
+          <a:p>
+            <a:pPr algn="ctr">
+              <a:lnSpc>
+                <a:spcPct val="108000"/>
+              </a:lnSpc>
+              <a:spcAft>
+                <a:spcPts val="0"/>
+              </a:spcAft>
+              <a:defRPr sz="1500" b="0">
+                <a:solidFill>
+                  <a:srgbClr val="17212B"/>
+                </a:solidFill>
+                <a:latin typeface="Arial"/>
+              </a:defRPr>
+            </a:pPr>
+            <a:r>
+              <a:t>khớp ngày/chỉ số?</a:t>
+            </a:r>
+          </a:p>
+        </p:txBody>
+      </p:sp>
+      <p:cxnSp>
+        <p:nvCxnSpPr>
+          <p:cNvPr id="16" name="Connector 15"/>
+          <p:cNvCxnSpPr/>
+          <p:nvPr/>
+        </p:nvCxnSpPr>
+        <p:spPr>
+          <a:xfrm>
+            <a:off x="2743200" y="2286000"/>
+            <a:ext cx="457200" cy="0"/>
+          </a:xfrm>
+          <a:prstGeom prst="line">
+            <a:avLst/>
+          </a:prstGeom>
+          <a:ln w="14604">
+            <a:solidFill>
+              <a:srgbClr val="59636E"/>
+            </a:solidFill>
+            <a:tailEnd type="triangle"/>
+          </a:ln>
+          <a:effectLst/>
+        </p:spPr>
+        <p:style>
+          <a:lnRef idx="2">
+            <a:schemeClr val="accent1"/>
+          </a:lnRef>
+          <a:fillRef idx="0">
+            <a:schemeClr val="accent1"/>
+          </a:fillRef>
+          <a:effectRef idx="0">
+            <a:schemeClr val="accent1"/>
+          </a:effectRef>
+          <a:fontRef idx="minor">
+            <a:schemeClr val="tx1"/>
+          </a:fontRef>
+        </p:style>
+      </p:cxnSp>
+      <p:cxnSp>
+        <p:nvCxnSpPr>
+          <p:cNvPr id="17" name="Connector 16"/>
+          <p:cNvCxnSpPr/>
+          <p:nvPr/>
+        </p:nvCxnSpPr>
+        <p:spPr>
+          <a:xfrm>
+            <a:off x="5760720" y="2286000"/>
+            <a:ext cx="457200" cy="0"/>
+          </a:xfrm>
+          <a:prstGeom prst="line">
+            <a:avLst/>
+          </a:prstGeom>
+          <a:ln w="14604">
+            <a:solidFill>
+              <a:srgbClr val="59636E"/>
+            </a:solidFill>
+            <a:tailEnd type="triangle"/>
+          </a:ln>
+          <a:effectLst/>
+        </p:spPr>
+        <p:style>
+          <a:lnRef idx="2">
+            <a:schemeClr val="accent1"/>
+          </a:lnRef>
+          <a:fillRef idx="0">
+            <a:schemeClr val="accent1"/>
+          </a:fillRef>
+          <a:effectRef idx="0">
+            <a:schemeClr val="accent1"/>
+          </a:effectRef>
+          <a:fontRef idx="minor">
+            <a:schemeClr val="tx1"/>
+          </a:fontRef>
+        </p:style>
+      </p:cxnSp>
+      <p:sp>
+        <p:nvSpPr>
+          <p:cNvPr id="18" name="Rectangle 17"/>
+          <p:cNvSpPr/>
+          <p:nvPr/>
+        </p:nvSpPr>
+        <p:spPr>
+          <a:xfrm>
+            <a:off x="5760720" y="1965960"/>
+            <a:ext cx="457200" cy="237744"/>
+          </a:xfrm>
+          <a:prstGeom prst="rect">
+            <a:avLst/>
+          </a:prstGeom>
+          <a:solidFill>
+            <a:srgbClr val="FFFFFF"/>
+          </a:solidFill>
+          <a:ln>
+            <a:noFill/>
+          </a:ln>
+          <a:effectLst/>
+        </p:spPr>
+        <p:style>
+          <a:lnRef idx="1">
+            <a:schemeClr val="accent1"/>
+          </a:lnRef>
+          <a:fillRef idx="3">
+            <a:schemeClr val="accent1"/>
+          </a:fillRef>
+          <a:effectRef idx="0">
+            <a:schemeClr val="accent1"/>
+          </a:effectRef>
+          <a:fontRef idx="minor">
+            <a:schemeClr val="lt1"/>
+          </a:fontRef>
+        </p:style>
+        <p:txBody>
+          <a:bodyPr rtlCol="0" anchor="ctr"/>
+          <a:lstStyle/>
+          <a:p>
+            <a:pPr algn="ctr"/>
+          </a:p>
+        </p:txBody>
+      </p:sp>
+      <p:sp>
+        <p:nvSpPr>
+          <p:cNvPr id="19" name="TextBox 18"/>
+          <p:cNvSpPr txBox="1"/>
+          <p:nvPr/>
+        </p:nvSpPr>
+        <p:spPr>
+          <a:xfrm>
+            <a:off x="5760720" y="1965960"/>
+            <a:ext cx="457200" cy="228600"/>
+          </a:xfrm>
+          <a:prstGeom prst="rect">
+            <a:avLst/>
+          </a:prstGeom>
+          <a:noFill/>
+        </p:spPr>
+        <p:txBody>
+          <a:bodyPr wrap="square" lIns="0" rIns="0" tIns="0" bIns="0">
+            <a:noAutofit/>
+          </a:bodyPr>
+          <a:lstStyle/>
+          <a:p>
+            <a:pPr algn="ctr">
+              <a:lnSpc>
+                <a:spcPct val="108000"/>
+              </a:lnSpc>
+              <a:spcAft>
+                <a:spcPts val="0"/>
+              </a:spcAft>
+              <a:defRPr sz="1250" b="1">
+                <a:solidFill>
+                  <a:srgbClr val="59636E"/>
+                </a:solidFill>
+                <a:latin typeface="Arial"/>
+              </a:defRPr>
+            </a:pPr>
+            <a:r>
+              <a:t>Có</a:t>
+            </a:r>
+          </a:p>
+        </p:txBody>
+      </p:sp>
+      <p:cxnSp>
+        <p:nvCxnSpPr>
+          <p:cNvPr id="20" name="Connector 19"/>
+          <p:cNvCxnSpPr/>
+          <p:nvPr/>
+        </p:nvCxnSpPr>
+        <p:spPr>
+          <a:xfrm>
+            <a:off x="8595360" y="2286000"/>
+            <a:ext cx="548640" cy="0"/>
+          </a:xfrm>
+          <a:prstGeom prst="line">
+            <a:avLst/>
+          </a:prstGeom>
+          <a:ln w="14604">
+            <a:solidFill>
+              <a:srgbClr val="59636E"/>
+            </a:solidFill>
+            <a:tailEnd type="triangle"/>
+          </a:ln>
+          <a:effectLst/>
+        </p:spPr>
+        <p:style>
+          <a:lnRef idx="2">
+            <a:schemeClr val="accent1"/>
+          </a:lnRef>
+          <a:fillRef idx="0">
+            <a:schemeClr val="accent1"/>
+          </a:fillRef>
+          <a:effectRef idx="0">
+            <a:schemeClr val="accent1"/>
+          </a:effectRef>
+          <a:fontRef idx="minor">
+            <a:schemeClr val="tx1"/>
+          </a:fontRef>
+        </p:style>
+      </p:cxnSp>
+      <p:sp>
+        <p:nvSpPr>
+          <p:cNvPr id="21" name="Rectangle 20"/>
+          <p:cNvSpPr/>
+          <p:nvPr/>
+        </p:nvSpPr>
+        <p:spPr>
+          <a:xfrm>
+            <a:off x="3200400" y="3337560"/>
+            <a:ext cx="2560320" cy="731520"/>
+          </a:xfrm>
+          <a:prstGeom prst="rect">
+            <a:avLst/>
+          </a:prstGeom>
+          <a:solidFill>
+            <a:srgbClr val="FFFFFF"/>
+          </a:solidFill>
+          <a:ln w="12700">
+            <a:solidFill>
+              <a:srgbClr val="284A63"/>
+            </a:solidFill>
+          </a:ln>
+          <a:effectLst/>
+        </p:spPr>
+        <p:style>
+          <a:lnRef idx="1">
+            <a:schemeClr val="accent1"/>
+          </a:lnRef>
+          <a:fillRef idx="3">
+            <a:schemeClr val="accent1"/>
+          </a:fillRef>
+          <a:effectRef idx="0">
+            <a:schemeClr val="accent1"/>
+          </a:effectRef>
+          <a:fontRef idx="minor">
+            <a:schemeClr val="lt1"/>
+          </a:fontRef>
+        </p:style>
+        <p:txBody>
+          <a:bodyPr rtlCol="0" anchor="ctr"/>
+          <a:lstStyle/>
+          <a:p>
+            <a:pPr algn="ctr"/>
+          </a:p>
+        </p:txBody>
+      </p:sp>
+      <p:sp>
+        <p:nvSpPr>
+          <p:cNvPr id="22" name="TextBox 21"/>
+          <p:cNvSpPr txBox="1"/>
+          <p:nvPr/>
+        </p:nvSpPr>
+        <p:spPr>
+          <a:xfrm>
+            <a:off x="3291840" y="3383279"/>
+            <a:ext cx="2377439" cy="640080"/>
+          </a:xfrm>
+          <a:prstGeom prst="rect">
+            <a:avLst/>
+          </a:prstGeom>
+          <a:noFill/>
+        </p:spPr>
+        <p:txBody>
+          <a:bodyPr wrap="square" lIns="0" rIns="0" tIns="0" bIns="0" anchor="ctr">
+            <a:noAutofit/>
+          </a:bodyPr>
+          <a:lstStyle/>
+          <a:p>
+            <a:pPr algn="ctr">
+              <a:lnSpc>
+                <a:spcPct val="108000"/>
+              </a:lnSpc>
+              <a:spcAft>
+                <a:spcPts val="500"/>
+              </a:spcAft>
               <a:defRPr sz="1600" b="0">
                 <a:solidFill>
                   <a:srgbClr val="17212B"/>
@@ -26082,7 +27279,7 @@
               </a:defRPr>
             </a:pPr>
             <a:r>
-              <a:t>Đủ hóa đơn,</a:t>
+              <a:t>Dừng; thông báo</a:t>
             </a:r>
           </a:p>
           <a:p>
@@ -26101,21 +27298,128 @@
               </a:defRPr>
             </a:pPr>
             <a:r>
-              <a:t>khớp dữ liệu?</a:t>
+              <a:t>lý do cụ thể</a:t>
+            </a:r>
+          </a:p>
+        </p:txBody>
+      </p:sp>
+      <p:sp>
+        <p:nvSpPr>
+          <p:cNvPr id="23" name="Rectangle 22"/>
+          <p:cNvSpPr/>
+          <p:nvPr/>
+        </p:nvSpPr>
+        <p:spPr>
+          <a:xfrm>
+            <a:off x="9144000" y="3337560"/>
+            <a:ext cx="2560320" cy="731520"/>
+          </a:xfrm>
+          <a:prstGeom prst="rect">
+            <a:avLst/>
+          </a:prstGeom>
+          <a:solidFill>
+            <a:srgbClr val="FFFFFF"/>
+          </a:solidFill>
+          <a:ln w="12700">
+            <a:solidFill>
+              <a:srgbClr val="284A63"/>
+            </a:solidFill>
+          </a:ln>
+          <a:effectLst/>
+        </p:spPr>
+        <p:style>
+          <a:lnRef idx="1">
+            <a:schemeClr val="accent1"/>
+          </a:lnRef>
+          <a:fillRef idx="3">
+            <a:schemeClr val="accent1"/>
+          </a:fillRef>
+          <a:effectRef idx="0">
+            <a:schemeClr val="accent1"/>
+          </a:effectRef>
+          <a:fontRef idx="minor">
+            <a:schemeClr val="lt1"/>
+          </a:fontRef>
+        </p:style>
+        <p:txBody>
+          <a:bodyPr rtlCol="0" anchor="ctr"/>
+          <a:lstStyle/>
+          <a:p>
+            <a:pPr algn="ctr"/>
+          </a:p>
+        </p:txBody>
+      </p:sp>
+      <p:sp>
+        <p:nvSpPr>
+          <p:cNvPr id="24" name="TextBox 23"/>
+          <p:cNvSpPr txBox="1"/>
+          <p:nvPr/>
+        </p:nvSpPr>
+        <p:spPr>
+          <a:xfrm>
+            <a:off x="9235440" y="3383279"/>
+            <a:ext cx="2377439" cy="640080"/>
+          </a:xfrm>
+          <a:prstGeom prst="rect">
+            <a:avLst/>
+          </a:prstGeom>
+          <a:noFill/>
+        </p:spPr>
+        <p:txBody>
+          <a:bodyPr wrap="square" lIns="0" rIns="0" tIns="0" bIns="0" anchor="ctr">
+            <a:noAutofit/>
+          </a:bodyPr>
+          <a:lstStyle/>
+          <a:p>
+            <a:pPr algn="ctr">
+              <a:lnSpc>
+                <a:spcPct val="108000"/>
+              </a:lnSpc>
+              <a:spcAft>
+                <a:spcPts val="500"/>
+              </a:spcAft>
+              <a:defRPr sz="1600" b="0">
+                <a:solidFill>
+                  <a:srgbClr val="17212B"/>
+                </a:solidFill>
+                <a:latin typeface="Arial"/>
+              </a:defRPr>
+            </a:pPr>
+            <a:r>
+              <a:t>Dừng; bổ sung</a:t>
+            </a:r>
+          </a:p>
+          <a:p>
+            <a:pPr algn="ctr">
+              <a:lnSpc>
+                <a:spcPct val="108000"/>
+              </a:lnSpc>
+              <a:spcAft>
+                <a:spcPts val="0"/>
+              </a:spcAft>
+              <a:defRPr sz="1600" b="0">
+                <a:solidFill>
+                  <a:srgbClr val="17212B"/>
+                </a:solidFill>
+                <a:latin typeface="Arial"/>
+              </a:defRPr>
+            </a:pPr>
+            <a:r>
+              <a:t>hoặc kiểm tra lại</a:t>
             </a:r>
           </a:p>
         </p:txBody>
       </p:sp>
       <p:cxnSp>
         <p:nvCxnSpPr>
-          <p:cNvPr id="16" name="Connector 15"/>
+          <p:cNvPr id="25" name="Connector 24"/>
           <p:cNvCxnSpPr/>
           <p:nvPr/>
         </p:nvCxnSpPr>
         <p:spPr>
           <a:xfrm>
-            <a:off x="2743200" y="2286000"/>
-            <a:ext cx="457200" cy="0"/>
+            <a:off x="4480560" y="2834640"/>
+            <a:ext cx="0" cy="502920"/>
           </a:xfrm>
           <a:prstGeom prst="line">
             <a:avLst/>
@@ -26143,53 +27447,16 @@
           </a:fontRef>
         </p:style>
       </p:cxnSp>
-      <p:cxnSp>
-        <p:nvCxnSpPr>
-          <p:cNvPr id="17" name="Connector 16"/>
-          <p:cNvCxnSpPr/>
-          <p:nvPr/>
-        </p:nvCxnSpPr>
-        <p:spPr>
-          <a:xfrm>
-            <a:off x="5760720" y="2286000"/>
-            <a:ext cx="457200" cy="0"/>
-          </a:xfrm>
-          <a:prstGeom prst="line">
-            <a:avLst/>
-          </a:prstGeom>
-          <a:ln w="14604">
-            <a:solidFill>
-              <a:srgbClr val="59636E"/>
-            </a:solidFill>
-            <a:tailEnd type="triangle"/>
-          </a:ln>
-          <a:effectLst/>
-        </p:spPr>
-        <p:style>
-          <a:lnRef idx="2">
-            <a:schemeClr val="accent1"/>
-          </a:lnRef>
-          <a:fillRef idx="0">
-            <a:schemeClr val="accent1"/>
-          </a:fillRef>
-          <a:effectRef idx="0">
-            <a:schemeClr val="accent1"/>
-          </a:effectRef>
-          <a:fontRef idx="minor">
-            <a:schemeClr val="tx1"/>
-          </a:fontRef>
-        </p:style>
-      </p:cxnSp>
-      <p:sp>
-        <p:nvSpPr>
-          <p:cNvPr id="18" name="Rectangle 17"/>
+      <p:sp>
+        <p:nvSpPr>
+          <p:cNvPr id="26" name="Rectangle 25"/>
           <p:cNvSpPr/>
           <p:nvPr/>
         </p:nvSpPr>
         <p:spPr>
           <a:xfrm>
-            <a:off x="5760720" y="1965960"/>
-            <a:ext cx="457200" cy="237744"/>
+            <a:off x="4572000" y="3017520"/>
+            <a:ext cx="594360" cy="237744"/>
           </a:xfrm>
           <a:prstGeom prst="rect">
             <a:avLst/>
@@ -26226,14 +27493,14 @@
       </p:sp>
       <p:sp>
         <p:nvSpPr>
-          <p:cNvPr id="19" name="TextBox 18"/>
+          <p:cNvPr id="27" name="TextBox 26"/>
           <p:cNvSpPr txBox="1"/>
           <p:nvPr/>
         </p:nvSpPr>
         <p:spPr>
           <a:xfrm>
-            <a:off x="5760720" y="1965960"/>
-            <a:ext cx="457200" cy="228600"/>
+            <a:off x="4572000" y="3017520"/>
+            <a:ext cx="594360" cy="228600"/>
           </a:xfrm>
           <a:prstGeom prst="rect">
             <a:avLst/>
@@ -26261,21 +27528,21 @@
               </a:defRPr>
             </a:pPr>
             <a:r>
-              <a:t>Có</a:t>
+              <a:t>Không</a:t>
             </a:r>
           </a:p>
         </p:txBody>
       </p:sp>
       <p:cxnSp>
         <p:nvCxnSpPr>
-          <p:cNvPr id="20" name="Connector 19"/>
+          <p:cNvPr id="28" name="Connector 27"/>
           <p:cNvCxnSpPr/>
           <p:nvPr/>
         </p:nvCxnSpPr>
         <p:spPr>
           <a:xfrm>
-            <a:off x="8595360" y="2286000"/>
-            <a:ext cx="548640" cy="0"/>
+            <a:off x="10424160" y="2834640"/>
+            <a:ext cx="0" cy="502920"/>
           </a:xfrm>
           <a:prstGeom prst="line">
             <a:avLst/>
@@ -26305,14 +27572,100 @@
       </p:cxnSp>
       <p:sp>
         <p:nvSpPr>
-          <p:cNvPr id="21" name="Rectangle 20"/>
+          <p:cNvPr id="29" name="Rectangle 28"/>
           <p:cNvSpPr/>
           <p:nvPr/>
         </p:nvSpPr>
         <p:spPr>
           <a:xfrm>
-            <a:off x="3200400" y="3337560"/>
-            <a:ext cx="2560320" cy="731520"/>
+            <a:off x="10561320" y="3017520"/>
+            <a:ext cx="594360" cy="237744"/>
+          </a:xfrm>
+          <a:prstGeom prst="rect">
+            <a:avLst/>
+          </a:prstGeom>
+          <a:solidFill>
+            <a:srgbClr val="FFFFFF"/>
+          </a:solidFill>
+          <a:ln>
+            <a:noFill/>
+          </a:ln>
+          <a:effectLst/>
+        </p:spPr>
+        <p:style>
+          <a:lnRef idx="1">
+            <a:schemeClr val="accent1"/>
+          </a:lnRef>
+          <a:fillRef idx="3">
+            <a:schemeClr val="accent1"/>
+          </a:fillRef>
+          <a:effectRef idx="0">
+            <a:schemeClr val="accent1"/>
+          </a:effectRef>
+          <a:fontRef idx="minor">
+            <a:schemeClr val="lt1"/>
+          </a:fontRef>
+        </p:style>
+        <p:txBody>
+          <a:bodyPr rtlCol="0" anchor="ctr"/>
+          <a:lstStyle/>
+          <a:p>
+            <a:pPr algn="ctr"/>
+          </a:p>
+        </p:txBody>
+      </p:sp>
+      <p:sp>
+        <p:nvSpPr>
+          <p:cNvPr id="30" name="TextBox 29"/>
+          <p:cNvSpPr txBox="1"/>
+          <p:nvPr/>
+        </p:nvSpPr>
+        <p:spPr>
+          <a:xfrm>
+            <a:off x="10561320" y="3017520"/>
+            <a:ext cx="594360" cy="228600"/>
+          </a:xfrm>
+          <a:prstGeom prst="rect">
+            <a:avLst/>
+          </a:prstGeom>
+          <a:noFill/>
+        </p:spPr>
+        <p:txBody>
+          <a:bodyPr wrap="square" lIns="0" rIns="0" tIns="0" bIns="0">
+            <a:noAutofit/>
+          </a:bodyPr>
+          <a:lstStyle/>
+          <a:p>
+            <a:pPr algn="ctr">
+              <a:lnSpc>
+                <a:spcPct val="108000"/>
+              </a:lnSpc>
+              <a:spcAft>
+                <a:spcPts val="0"/>
+              </a:spcAft>
+              <a:defRPr sz="1250" b="1">
+                <a:solidFill>
+                  <a:srgbClr val="59636E"/>
+                </a:solidFill>
+                <a:latin typeface="Arial"/>
+              </a:defRPr>
+            </a:pPr>
+            <a:r>
+              <a:t>Không</a:t>
+            </a:r>
+          </a:p>
+        </p:txBody>
+      </p:sp>
+      <p:sp>
+        <p:nvSpPr>
+          <p:cNvPr id="31" name="Rectangle 30"/>
+          <p:cNvSpPr/>
+          <p:nvPr/>
+        </p:nvSpPr>
+        <p:spPr>
+          <a:xfrm>
+            <a:off x="6080760" y="3931920"/>
+            <a:ext cx="2834640" cy="594360"/>
           </a:xfrm>
           <a:prstGeom prst="rect">
             <a:avLst/>
@@ -26351,14 +27704,297 @@
       </p:sp>
       <p:sp>
         <p:nvSpPr>
-          <p:cNvPr id="22" name="TextBox 21"/>
+          <p:cNvPr id="32" name="TextBox 31"/>
           <p:cNvSpPr txBox="1"/>
           <p:nvPr/>
         </p:nvSpPr>
         <p:spPr>
           <a:xfrm>
-            <a:off x="3291840" y="3383279"/>
-            <a:ext cx="2377439" cy="640080"/>
+            <a:off x="6172200" y="3977639"/>
+            <a:ext cx="2651760" cy="502920"/>
+          </a:xfrm>
+          <a:prstGeom prst="rect">
+            <a:avLst/>
+          </a:prstGeom>
+          <a:noFill/>
+        </p:spPr>
+        <p:txBody>
+          <a:bodyPr wrap="square" lIns="0" rIns="0" tIns="0" bIns="0" anchor="ctr">
+            <a:noAutofit/>
+          </a:bodyPr>
+          <a:lstStyle/>
+          <a:p>
+            <a:pPr algn="ctr">
+              <a:lnSpc>
+                <a:spcPct val="108000"/>
+              </a:lnSpc>
+              <a:spcAft>
+                <a:spcPts val="0"/>
+              </a:spcAft>
+              <a:defRPr sz="1800" b="0">
+                <a:solidFill>
+                  <a:srgbClr val="17212B"/>
+                </a:solidFill>
+                <a:latin typeface="Arial"/>
+              </a:defRPr>
+            </a:pPr>
+            <a:r>
+              <a:t>Cọc − Thiệt hại − Nợ</a:t>
+            </a:r>
+          </a:p>
+        </p:txBody>
+      </p:sp>
+      <p:cxnSp>
+        <p:nvCxnSpPr>
+          <p:cNvPr id="33" name="Connector 32"/>
+          <p:cNvCxnSpPr/>
+          <p:nvPr/>
+        </p:nvCxnSpPr>
+        <p:spPr>
+          <a:xfrm>
+            <a:off x="11704320" y="2286000"/>
+            <a:ext cx="182880" cy="0"/>
+          </a:xfrm>
+          <a:prstGeom prst="line">
+            <a:avLst/>
+          </a:prstGeom>
+          <a:ln w="14604">
+            <a:solidFill>
+              <a:srgbClr val="59636E"/>
+            </a:solidFill>
+          </a:ln>
+          <a:effectLst/>
+        </p:spPr>
+        <p:style>
+          <a:lnRef idx="2">
+            <a:schemeClr val="accent1"/>
+          </a:lnRef>
+          <a:fillRef idx="0">
+            <a:schemeClr val="accent1"/>
+          </a:fillRef>
+          <a:effectRef idx="0">
+            <a:schemeClr val="accent1"/>
+          </a:effectRef>
+          <a:fontRef idx="minor">
+            <a:schemeClr val="tx1"/>
+          </a:fontRef>
+        </p:style>
+      </p:cxnSp>
+      <p:cxnSp>
+        <p:nvCxnSpPr>
+          <p:cNvPr id="34" name="Connector 33"/>
+          <p:cNvCxnSpPr/>
+          <p:nvPr/>
+        </p:nvCxnSpPr>
+        <p:spPr>
+          <a:xfrm>
+            <a:off x="11887200" y="2286000"/>
+            <a:ext cx="0" cy="1938528"/>
+          </a:xfrm>
+          <a:prstGeom prst="line">
+            <a:avLst/>
+          </a:prstGeom>
+          <a:ln w="14604">
+            <a:solidFill>
+              <a:srgbClr val="59636E"/>
+            </a:solidFill>
+          </a:ln>
+          <a:effectLst/>
+        </p:spPr>
+        <p:style>
+          <a:lnRef idx="2">
+            <a:schemeClr val="accent1"/>
+          </a:lnRef>
+          <a:fillRef idx="0">
+            <a:schemeClr val="accent1"/>
+          </a:fillRef>
+          <a:effectRef idx="0">
+            <a:schemeClr val="accent1"/>
+          </a:effectRef>
+          <a:fontRef idx="minor">
+            <a:schemeClr val="tx1"/>
+          </a:fontRef>
+        </p:style>
+      </p:cxnSp>
+      <p:cxnSp>
+        <p:nvCxnSpPr>
+          <p:cNvPr id="35" name="Connector 34"/>
+          <p:cNvCxnSpPr/>
+          <p:nvPr/>
+        </p:nvCxnSpPr>
+        <p:spPr>
+          <a:xfrm flipH="1">
+            <a:off x="8915400" y="4224528"/>
+            <a:ext cx="2971800" cy="0"/>
+          </a:xfrm>
+          <a:prstGeom prst="line">
+            <a:avLst/>
+          </a:prstGeom>
+          <a:ln w="14604">
+            <a:solidFill>
+              <a:srgbClr val="59636E"/>
+            </a:solidFill>
+            <a:tailEnd type="triangle"/>
+          </a:ln>
+          <a:effectLst/>
+        </p:spPr>
+        <p:style>
+          <a:lnRef idx="2">
+            <a:schemeClr val="accent1"/>
+          </a:lnRef>
+          <a:fillRef idx="0">
+            <a:schemeClr val="accent1"/>
+          </a:fillRef>
+          <a:effectRef idx="0">
+            <a:schemeClr val="accent1"/>
+          </a:effectRef>
+          <a:fontRef idx="minor">
+            <a:schemeClr val="tx1"/>
+          </a:fontRef>
+        </p:style>
+      </p:cxnSp>
+      <p:sp>
+        <p:nvSpPr>
+          <p:cNvPr id="36" name="Rectangle 35"/>
+          <p:cNvSpPr/>
+          <p:nvPr/>
+        </p:nvSpPr>
+        <p:spPr>
+          <a:xfrm>
+            <a:off x="11155680" y="3977639"/>
+            <a:ext cx="457200" cy="237744"/>
+          </a:xfrm>
+          <a:prstGeom prst="rect">
+            <a:avLst/>
+          </a:prstGeom>
+          <a:solidFill>
+            <a:srgbClr val="FFFFFF"/>
+          </a:solidFill>
+          <a:ln>
+            <a:noFill/>
+          </a:ln>
+          <a:effectLst/>
+        </p:spPr>
+        <p:style>
+          <a:lnRef idx="1">
+            <a:schemeClr val="accent1"/>
+          </a:lnRef>
+          <a:fillRef idx="3">
+            <a:schemeClr val="accent1"/>
+          </a:fillRef>
+          <a:effectRef idx="0">
+            <a:schemeClr val="accent1"/>
+          </a:effectRef>
+          <a:fontRef idx="minor">
+            <a:schemeClr val="lt1"/>
+          </a:fontRef>
+        </p:style>
+        <p:txBody>
+          <a:bodyPr rtlCol="0" anchor="ctr"/>
+          <a:lstStyle/>
+          <a:p>
+            <a:pPr algn="ctr"/>
+          </a:p>
+        </p:txBody>
+      </p:sp>
+      <p:sp>
+        <p:nvSpPr>
+          <p:cNvPr id="37" name="TextBox 36"/>
+          <p:cNvSpPr txBox="1"/>
+          <p:nvPr/>
+        </p:nvSpPr>
+        <p:spPr>
+          <a:xfrm>
+            <a:off x="11155680" y="3977639"/>
+            <a:ext cx="457200" cy="228600"/>
+          </a:xfrm>
+          <a:prstGeom prst="rect">
+            <a:avLst/>
+          </a:prstGeom>
+          <a:noFill/>
+        </p:spPr>
+        <p:txBody>
+          <a:bodyPr wrap="square" lIns="0" rIns="0" tIns="0" bIns="0">
+            <a:noAutofit/>
+          </a:bodyPr>
+          <a:lstStyle/>
+          <a:p>
+            <a:pPr algn="ctr">
+              <a:lnSpc>
+                <a:spcPct val="108000"/>
+              </a:lnSpc>
+              <a:spcAft>
+                <a:spcPts val="0"/>
+              </a:spcAft>
+              <a:defRPr sz="1250" b="1">
+                <a:solidFill>
+                  <a:srgbClr val="59636E"/>
+                </a:solidFill>
+                <a:latin typeface="Arial"/>
+              </a:defRPr>
+            </a:pPr>
+            <a:r>
+              <a:t>Có</a:t>
+            </a:r>
+          </a:p>
+        </p:txBody>
+      </p:sp>
+      <p:sp>
+        <p:nvSpPr>
+          <p:cNvPr id="38" name="Rectangle 37"/>
+          <p:cNvSpPr/>
+          <p:nvPr/>
+        </p:nvSpPr>
+        <p:spPr>
+          <a:xfrm>
+            <a:off x="5166360" y="4681728"/>
+            <a:ext cx="4663440" cy="594360"/>
+          </a:xfrm>
+          <a:prstGeom prst="rect">
+            <a:avLst/>
+          </a:prstGeom>
+          <a:solidFill>
+            <a:srgbClr val="FFFFFF"/>
+          </a:solidFill>
+          <a:ln w="12700">
+            <a:solidFill>
+              <a:srgbClr val="284A63"/>
+            </a:solidFill>
+          </a:ln>
+          <a:effectLst/>
+        </p:spPr>
+        <p:style>
+          <a:lnRef idx="1">
+            <a:schemeClr val="accent1"/>
+          </a:lnRef>
+          <a:fillRef idx="3">
+            <a:schemeClr val="accent1"/>
+          </a:fillRef>
+          <a:effectRef idx="0">
+            <a:schemeClr val="accent1"/>
+          </a:effectRef>
+          <a:fontRef idx="minor">
+            <a:schemeClr val="lt1"/>
+          </a:fontRef>
+        </p:style>
+        <p:txBody>
+          <a:bodyPr rtlCol="0" anchor="ctr"/>
+          <a:lstStyle/>
+          <a:p>
+            <a:pPr algn="ctr"/>
+          </a:p>
+        </p:txBody>
+      </p:sp>
+      <p:sp>
+        <p:nvSpPr>
+          <p:cNvPr id="39" name="TextBox 38"/>
+          <p:cNvSpPr txBox="1"/>
+          <p:nvPr/>
+        </p:nvSpPr>
+        <p:spPr>
+          <a:xfrm>
+            <a:off x="5257800" y="4727448"/>
+            <a:ext cx="4480559" cy="502920"/>
           </a:xfrm>
           <a:prstGeom prst="rect">
             <a:avLst/>
@@ -26378,7 +28014,7 @@
               <a:spcAft>
                 <a:spcPts val="500"/>
               </a:spcAft>
-              <a:defRPr sz="1600" b="0">
+              <a:defRPr sz="1450" b="0">
                 <a:solidFill>
                   <a:srgbClr val="17212B"/>
                 </a:solidFill>
@@ -26386,9 +28022,222 @@
               </a:defRPr>
             </a:pPr>
             <a:r>
-              <a:t>Dừng; thông báo</a:t>
-            </a:r>
-          </a:p>
+              <a:t>Lưu quyết toán; cấn cọc; kết thúc hợp đồng</a:t>
+            </a:r>
+          </a:p>
+          <a:p>
+            <a:pPr algn="ctr">
+              <a:lnSpc>
+                <a:spcPct val="108000"/>
+              </a:lnSpc>
+              <a:spcAft>
+                <a:spcPts val="0"/>
+              </a:spcAft>
+              <a:defRPr sz="1450" b="0">
+                <a:solidFill>
+                  <a:srgbClr val="17212B"/>
+                </a:solidFill>
+                <a:latin typeface="Arial"/>
+              </a:defRPr>
+            </a:pPr>
+            <a:r>
+              <a:t>Trong cùng một transaction</a:t>
+            </a:r>
+          </a:p>
+        </p:txBody>
+      </p:sp>
+      <p:cxnSp>
+        <p:nvCxnSpPr>
+          <p:cNvPr id="40" name="Connector 39"/>
+          <p:cNvCxnSpPr/>
+          <p:nvPr/>
+        </p:nvCxnSpPr>
+        <p:spPr>
+          <a:xfrm>
+            <a:off x="7498079" y="4526280"/>
+            <a:ext cx="0" cy="155448"/>
+          </a:xfrm>
+          <a:prstGeom prst="line">
+            <a:avLst/>
+          </a:prstGeom>
+          <a:ln w="14604">
+            <a:solidFill>
+              <a:srgbClr val="59636E"/>
+            </a:solidFill>
+            <a:tailEnd type="triangle"/>
+          </a:ln>
+          <a:effectLst/>
+        </p:spPr>
+        <p:style>
+          <a:lnRef idx="2">
+            <a:schemeClr val="accent1"/>
+          </a:lnRef>
+          <a:fillRef idx="0">
+            <a:schemeClr val="accent1"/>
+          </a:fillRef>
+          <a:effectRef idx="0">
+            <a:schemeClr val="accent1"/>
+          </a:effectRef>
+          <a:fontRef idx="minor">
+            <a:schemeClr val="tx1"/>
+          </a:fontRef>
+        </p:style>
+      </p:cxnSp>
+      <p:sp>
+        <p:nvSpPr>
+          <p:cNvPr id="41" name="Rectangle 40"/>
+          <p:cNvSpPr/>
+          <p:nvPr/>
+        </p:nvSpPr>
+        <p:spPr>
+          <a:xfrm>
+            <a:off x="594360" y="5486400"/>
+            <a:ext cx="3383280" cy="585216"/>
+          </a:xfrm>
+          <a:prstGeom prst="rect">
+            <a:avLst/>
+          </a:prstGeom>
+          <a:solidFill>
+            <a:srgbClr val="FFFFFF"/>
+          </a:solidFill>
+          <a:ln w="12700">
+            <a:solidFill>
+              <a:srgbClr val="284A63"/>
+            </a:solidFill>
+          </a:ln>
+          <a:effectLst/>
+        </p:spPr>
+        <p:style>
+          <a:lnRef idx="1">
+            <a:schemeClr val="accent1"/>
+          </a:lnRef>
+          <a:fillRef idx="3">
+            <a:schemeClr val="accent1"/>
+          </a:fillRef>
+          <a:effectRef idx="0">
+            <a:schemeClr val="accent1"/>
+          </a:effectRef>
+          <a:fontRef idx="minor">
+            <a:schemeClr val="lt1"/>
+          </a:fontRef>
+        </p:style>
+        <p:txBody>
+          <a:bodyPr rtlCol="0" anchor="ctr"/>
+          <a:lstStyle/>
+          <a:p>
+            <a:pPr algn="ctr"/>
+          </a:p>
+        </p:txBody>
+      </p:sp>
+      <p:sp>
+        <p:nvSpPr>
+          <p:cNvPr id="42" name="TextBox 41"/>
+          <p:cNvSpPr txBox="1"/>
+          <p:nvPr/>
+        </p:nvSpPr>
+        <p:spPr>
+          <a:xfrm>
+            <a:off x="685800" y="5532120"/>
+            <a:ext cx="3200400" cy="493776"/>
+          </a:xfrm>
+          <a:prstGeom prst="rect">
+            <a:avLst/>
+          </a:prstGeom>
+          <a:noFill/>
+        </p:spPr>
+        <p:txBody>
+          <a:bodyPr wrap="square" lIns="0" rIns="0" tIns="0" bIns="0" anchor="ctr">
+            <a:noAutofit/>
+          </a:bodyPr>
+          <a:lstStyle/>
+          <a:p>
+            <a:pPr algn="ctr">
+              <a:lnSpc>
+                <a:spcPct val="108000"/>
+              </a:lnSpc>
+              <a:spcAft>
+                <a:spcPts val="0"/>
+              </a:spcAft>
+              <a:defRPr sz="1800" b="0">
+                <a:solidFill>
+                  <a:srgbClr val="17212B"/>
+                </a:solidFill>
+                <a:latin typeface="Arial"/>
+              </a:defRPr>
+            </a:pPr>
+            <a:r>
+              <a:t>Dương: hoàn tiền</a:t>
+            </a:r>
+          </a:p>
+        </p:txBody>
+      </p:sp>
+      <p:sp>
+        <p:nvSpPr>
+          <p:cNvPr id="43" name="Rectangle 42"/>
+          <p:cNvSpPr/>
+          <p:nvPr/>
+        </p:nvSpPr>
+        <p:spPr>
+          <a:xfrm>
+            <a:off x="4389120" y="5486400"/>
+            <a:ext cx="3383280" cy="585216"/>
+          </a:xfrm>
+          <a:prstGeom prst="rect">
+            <a:avLst/>
+          </a:prstGeom>
+          <a:solidFill>
+            <a:srgbClr val="FFFFFF"/>
+          </a:solidFill>
+          <a:ln w="12700">
+            <a:solidFill>
+              <a:srgbClr val="284A63"/>
+            </a:solidFill>
+          </a:ln>
+          <a:effectLst/>
+        </p:spPr>
+        <p:style>
+          <a:lnRef idx="1">
+            <a:schemeClr val="accent1"/>
+          </a:lnRef>
+          <a:fillRef idx="3">
+            <a:schemeClr val="accent1"/>
+          </a:fillRef>
+          <a:effectRef idx="0">
+            <a:schemeClr val="accent1"/>
+          </a:effectRef>
+          <a:fontRef idx="minor">
+            <a:schemeClr val="lt1"/>
+          </a:fontRef>
+        </p:style>
+        <p:txBody>
+          <a:bodyPr rtlCol="0" anchor="ctr"/>
+          <a:lstStyle/>
+          <a:p>
+            <a:pPr algn="ctr"/>
+          </a:p>
+        </p:txBody>
+      </p:sp>
+      <p:sp>
+        <p:nvSpPr>
+          <p:cNvPr id="44" name="TextBox 43"/>
+          <p:cNvSpPr txBox="1"/>
+          <p:nvPr/>
+        </p:nvSpPr>
+        <p:spPr>
+          <a:xfrm>
+            <a:off x="4480559" y="5532120"/>
+            <a:ext cx="3200400" cy="493776"/>
+          </a:xfrm>
+          <a:prstGeom prst="rect">
+            <a:avLst/>
+          </a:prstGeom>
+          <a:noFill/>
+        </p:spPr>
+        <p:txBody>
+          <a:bodyPr wrap="square" lIns="0" rIns="0" tIns="0" bIns="0" anchor="ctr">
+            <a:noAutofit/>
+          </a:bodyPr>
+          <a:lstStyle/>
           <a:p>
             <a:pPr algn="ctr">
               <a:lnSpc>
@@ -26405,21 +28254,21 @@
               </a:defRPr>
             </a:pPr>
             <a:r>
-              <a:t>lý do cụ thể</a:t>
-            </a:r>
-          </a:p>
-        </p:txBody>
-      </p:sp>
-      <p:sp>
-        <p:nvSpPr>
-          <p:cNvPr id="23" name="Rectangle 22"/>
+              <a:t>Bằng 0: không hoàn / thu thêm</a:t>
+            </a:r>
+          </a:p>
+        </p:txBody>
+      </p:sp>
+      <p:sp>
+        <p:nvSpPr>
+          <p:cNvPr id="45" name="Rectangle 44"/>
           <p:cNvSpPr/>
           <p:nvPr/>
         </p:nvSpPr>
         <p:spPr>
           <a:xfrm>
-            <a:off x="9144000" y="3337560"/>
-            <a:ext cx="2560320" cy="731520"/>
+            <a:off x="8183879" y="5486400"/>
+            <a:ext cx="3383280" cy="585216"/>
           </a:xfrm>
           <a:prstGeom prst="rect">
             <a:avLst/>
@@ -26458,819 +28307,7 @@
       </p:sp>
       <p:sp>
         <p:nvSpPr>
-          <p:cNvPr id="24" name="TextBox 23"/>
-          <p:cNvSpPr txBox="1"/>
-          <p:nvPr/>
-        </p:nvSpPr>
-        <p:spPr>
-          <a:xfrm>
-            <a:off x="9235440" y="3383279"/>
-            <a:ext cx="2377439" cy="640080"/>
-          </a:xfrm>
-          <a:prstGeom prst="rect">
-            <a:avLst/>
-          </a:prstGeom>
-          <a:noFill/>
-        </p:spPr>
-        <p:txBody>
-          <a:bodyPr wrap="square" lIns="0" rIns="0" tIns="0" bIns="0" anchor="ctr">
-            <a:noAutofit/>
-          </a:bodyPr>
-          <a:lstStyle/>
-          <a:p>
-            <a:pPr algn="ctr">
-              <a:lnSpc>
-                <a:spcPct val="108000"/>
-              </a:lnSpc>
-              <a:spcAft>
-                <a:spcPts val="500"/>
-              </a:spcAft>
-              <a:defRPr sz="1600" b="0">
-                <a:solidFill>
-                  <a:srgbClr val="17212B"/>
-                </a:solidFill>
-                <a:latin typeface="Arial"/>
-              </a:defRPr>
-            </a:pPr>
-            <a:r>
-              <a:t>Dừng; bổ sung</a:t>
-            </a:r>
-          </a:p>
-          <a:p>
-            <a:pPr algn="ctr">
-              <a:lnSpc>
-                <a:spcPct val="108000"/>
-              </a:lnSpc>
-              <a:spcAft>
-                <a:spcPts val="0"/>
-              </a:spcAft>
-              <a:defRPr sz="1600" b="0">
-                <a:solidFill>
-                  <a:srgbClr val="17212B"/>
-                </a:solidFill>
-                <a:latin typeface="Arial"/>
-              </a:defRPr>
-            </a:pPr>
-            <a:r>
-              <a:t>hoặc kiểm tra lại</a:t>
-            </a:r>
-          </a:p>
-        </p:txBody>
-      </p:sp>
-      <p:cxnSp>
-        <p:nvCxnSpPr>
-          <p:cNvPr id="25" name="Connector 24"/>
-          <p:cNvCxnSpPr/>
-          <p:nvPr/>
-        </p:nvCxnSpPr>
-        <p:spPr>
-          <a:xfrm>
-            <a:off x="4480560" y="2834640"/>
-            <a:ext cx="0" cy="502920"/>
-          </a:xfrm>
-          <a:prstGeom prst="line">
-            <a:avLst/>
-          </a:prstGeom>
-          <a:ln w="14604">
-            <a:solidFill>
-              <a:srgbClr val="59636E"/>
-            </a:solidFill>
-            <a:tailEnd type="triangle"/>
-          </a:ln>
-          <a:effectLst/>
-        </p:spPr>
-        <p:style>
-          <a:lnRef idx="2">
-            <a:schemeClr val="accent1"/>
-          </a:lnRef>
-          <a:fillRef idx="0">
-            <a:schemeClr val="accent1"/>
-          </a:fillRef>
-          <a:effectRef idx="0">
-            <a:schemeClr val="accent1"/>
-          </a:effectRef>
-          <a:fontRef idx="minor">
-            <a:schemeClr val="tx1"/>
-          </a:fontRef>
-        </p:style>
-      </p:cxnSp>
-      <p:sp>
-        <p:nvSpPr>
-          <p:cNvPr id="26" name="Rectangle 25"/>
-          <p:cNvSpPr/>
-          <p:nvPr/>
-        </p:nvSpPr>
-        <p:spPr>
-          <a:xfrm>
-            <a:off x="4572000" y="3017520"/>
-            <a:ext cx="594360" cy="237744"/>
-          </a:xfrm>
-          <a:prstGeom prst="rect">
-            <a:avLst/>
-          </a:prstGeom>
-          <a:solidFill>
-            <a:srgbClr val="FFFFFF"/>
-          </a:solidFill>
-          <a:ln>
-            <a:noFill/>
-          </a:ln>
-          <a:effectLst/>
-        </p:spPr>
-        <p:style>
-          <a:lnRef idx="1">
-            <a:schemeClr val="accent1"/>
-          </a:lnRef>
-          <a:fillRef idx="3">
-            <a:schemeClr val="accent1"/>
-          </a:fillRef>
-          <a:effectRef idx="0">
-            <a:schemeClr val="accent1"/>
-          </a:effectRef>
-          <a:fontRef idx="minor">
-            <a:schemeClr val="lt1"/>
-          </a:fontRef>
-        </p:style>
-        <p:txBody>
-          <a:bodyPr rtlCol="0" anchor="ctr"/>
-          <a:lstStyle/>
-          <a:p>
-            <a:pPr algn="ctr"/>
-          </a:p>
-        </p:txBody>
-      </p:sp>
-      <p:sp>
-        <p:nvSpPr>
-          <p:cNvPr id="27" name="TextBox 26"/>
-          <p:cNvSpPr txBox="1"/>
-          <p:nvPr/>
-        </p:nvSpPr>
-        <p:spPr>
-          <a:xfrm>
-            <a:off x="4572000" y="3017520"/>
-            <a:ext cx="594360" cy="228600"/>
-          </a:xfrm>
-          <a:prstGeom prst="rect">
-            <a:avLst/>
-          </a:prstGeom>
-          <a:noFill/>
-        </p:spPr>
-        <p:txBody>
-          <a:bodyPr wrap="square" lIns="0" rIns="0" tIns="0" bIns="0">
-            <a:noAutofit/>
-          </a:bodyPr>
-          <a:lstStyle/>
-          <a:p>
-            <a:pPr algn="ctr">
-              <a:lnSpc>
-                <a:spcPct val="108000"/>
-              </a:lnSpc>
-              <a:spcAft>
-                <a:spcPts val="0"/>
-              </a:spcAft>
-              <a:defRPr sz="1250" b="1">
-                <a:solidFill>
-                  <a:srgbClr val="59636E"/>
-                </a:solidFill>
-                <a:latin typeface="Arial"/>
-              </a:defRPr>
-            </a:pPr>
-            <a:r>
-              <a:t>Không</a:t>
-            </a:r>
-          </a:p>
-        </p:txBody>
-      </p:sp>
-      <p:cxnSp>
-        <p:nvCxnSpPr>
-          <p:cNvPr id="28" name="Connector 27"/>
-          <p:cNvCxnSpPr/>
-          <p:nvPr/>
-        </p:nvCxnSpPr>
-        <p:spPr>
-          <a:xfrm>
-            <a:off x="10424160" y="2834640"/>
-            <a:ext cx="0" cy="502920"/>
-          </a:xfrm>
-          <a:prstGeom prst="line">
-            <a:avLst/>
-          </a:prstGeom>
-          <a:ln w="14604">
-            <a:solidFill>
-              <a:srgbClr val="59636E"/>
-            </a:solidFill>
-            <a:tailEnd type="triangle"/>
-          </a:ln>
-          <a:effectLst/>
-        </p:spPr>
-        <p:style>
-          <a:lnRef idx="2">
-            <a:schemeClr val="accent1"/>
-          </a:lnRef>
-          <a:fillRef idx="0">
-            <a:schemeClr val="accent1"/>
-          </a:fillRef>
-          <a:effectRef idx="0">
-            <a:schemeClr val="accent1"/>
-          </a:effectRef>
-          <a:fontRef idx="minor">
-            <a:schemeClr val="tx1"/>
-          </a:fontRef>
-        </p:style>
-      </p:cxnSp>
-      <p:sp>
-        <p:nvSpPr>
-          <p:cNvPr id="29" name="Rectangle 28"/>
-          <p:cNvSpPr/>
-          <p:nvPr/>
-        </p:nvSpPr>
-        <p:spPr>
-          <a:xfrm>
-            <a:off x="10561320" y="3017520"/>
-            <a:ext cx="594360" cy="237744"/>
-          </a:xfrm>
-          <a:prstGeom prst="rect">
-            <a:avLst/>
-          </a:prstGeom>
-          <a:solidFill>
-            <a:srgbClr val="FFFFFF"/>
-          </a:solidFill>
-          <a:ln>
-            <a:noFill/>
-          </a:ln>
-          <a:effectLst/>
-        </p:spPr>
-        <p:style>
-          <a:lnRef idx="1">
-            <a:schemeClr val="accent1"/>
-          </a:lnRef>
-          <a:fillRef idx="3">
-            <a:schemeClr val="accent1"/>
-          </a:fillRef>
-          <a:effectRef idx="0">
-            <a:schemeClr val="accent1"/>
-          </a:effectRef>
-          <a:fontRef idx="minor">
-            <a:schemeClr val="lt1"/>
-          </a:fontRef>
-        </p:style>
-        <p:txBody>
-          <a:bodyPr rtlCol="0" anchor="ctr"/>
-          <a:lstStyle/>
-          <a:p>
-            <a:pPr algn="ctr"/>
-          </a:p>
-        </p:txBody>
-      </p:sp>
-      <p:sp>
-        <p:nvSpPr>
-          <p:cNvPr id="30" name="TextBox 29"/>
-          <p:cNvSpPr txBox="1"/>
-          <p:nvPr/>
-        </p:nvSpPr>
-        <p:spPr>
-          <a:xfrm>
-            <a:off x="10561320" y="3017520"/>
-            <a:ext cx="594360" cy="228600"/>
-          </a:xfrm>
-          <a:prstGeom prst="rect">
-            <a:avLst/>
-          </a:prstGeom>
-          <a:noFill/>
-        </p:spPr>
-        <p:txBody>
-          <a:bodyPr wrap="square" lIns="0" rIns="0" tIns="0" bIns="0">
-            <a:noAutofit/>
-          </a:bodyPr>
-          <a:lstStyle/>
-          <a:p>
-            <a:pPr algn="ctr">
-              <a:lnSpc>
-                <a:spcPct val="108000"/>
-              </a:lnSpc>
-              <a:spcAft>
-                <a:spcPts val="0"/>
-              </a:spcAft>
-              <a:defRPr sz="1250" b="1">
-                <a:solidFill>
-                  <a:srgbClr val="59636E"/>
-                </a:solidFill>
-                <a:latin typeface="Arial"/>
-              </a:defRPr>
-            </a:pPr>
-            <a:r>
-              <a:t>Không</a:t>
-            </a:r>
-          </a:p>
-        </p:txBody>
-      </p:sp>
-      <p:sp>
-        <p:nvSpPr>
-          <p:cNvPr id="31" name="Rectangle 30"/>
-          <p:cNvSpPr/>
-          <p:nvPr/>
-        </p:nvSpPr>
-        <p:spPr>
-          <a:xfrm>
-            <a:off x="6080760" y="4343400"/>
-            <a:ext cx="2834640" cy="685800"/>
-          </a:xfrm>
-          <a:prstGeom prst="rect">
-            <a:avLst/>
-          </a:prstGeom>
-          <a:solidFill>
-            <a:srgbClr val="FFFFFF"/>
-          </a:solidFill>
-          <a:ln w="12700">
-            <a:solidFill>
-              <a:srgbClr val="284A63"/>
-            </a:solidFill>
-          </a:ln>
-          <a:effectLst/>
-        </p:spPr>
-        <p:style>
-          <a:lnRef idx="1">
-            <a:schemeClr val="accent1"/>
-          </a:lnRef>
-          <a:fillRef idx="3">
-            <a:schemeClr val="accent1"/>
-          </a:fillRef>
-          <a:effectRef idx="0">
-            <a:schemeClr val="accent1"/>
-          </a:effectRef>
-          <a:fontRef idx="minor">
-            <a:schemeClr val="lt1"/>
-          </a:fontRef>
-        </p:style>
-        <p:txBody>
-          <a:bodyPr rtlCol="0" anchor="ctr"/>
-          <a:lstStyle/>
-          <a:p>
-            <a:pPr algn="ctr"/>
-          </a:p>
-        </p:txBody>
-      </p:sp>
-      <p:sp>
-        <p:nvSpPr>
-          <p:cNvPr id="32" name="TextBox 31"/>
-          <p:cNvSpPr txBox="1"/>
-          <p:nvPr/>
-        </p:nvSpPr>
-        <p:spPr>
-          <a:xfrm>
-            <a:off x="6172200" y="4389120"/>
-            <a:ext cx="2651760" cy="594360"/>
-          </a:xfrm>
-          <a:prstGeom prst="rect">
-            <a:avLst/>
-          </a:prstGeom>
-          <a:noFill/>
-        </p:spPr>
-        <p:txBody>
-          <a:bodyPr wrap="square" lIns="0" rIns="0" tIns="0" bIns="0" anchor="ctr">
-            <a:noAutofit/>
-          </a:bodyPr>
-          <a:lstStyle/>
-          <a:p>
-            <a:pPr algn="ctr">
-              <a:lnSpc>
-                <a:spcPct val="108000"/>
-              </a:lnSpc>
-              <a:spcAft>
-                <a:spcPts val="0"/>
-              </a:spcAft>
-              <a:defRPr sz="1800" b="0">
-                <a:solidFill>
-                  <a:srgbClr val="17212B"/>
-                </a:solidFill>
-                <a:latin typeface="Arial"/>
-              </a:defRPr>
-            </a:pPr>
-            <a:r>
-              <a:t>Cọc − Thiệt hại − Nợ</a:t>
-            </a:r>
-          </a:p>
-        </p:txBody>
-      </p:sp>
-      <p:cxnSp>
-        <p:nvCxnSpPr>
-          <p:cNvPr id="33" name="Connector 32"/>
-          <p:cNvCxnSpPr/>
-          <p:nvPr/>
-        </p:nvCxnSpPr>
-        <p:spPr>
-          <a:xfrm>
-            <a:off x="11704320" y="2286000"/>
-            <a:ext cx="182880" cy="0"/>
-          </a:xfrm>
-          <a:prstGeom prst="line">
-            <a:avLst/>
-          </a:prstGeom>
-          <a:ln w="14604">
-            <a:solidFill>
-              <a:srgbClr val="59636E"/>
-            </a:solidFill>
-          </a:ln>
-          <a:effectLst/>
-        </p:spPr>
-        <p:style>
-          <a:lnRef idx="2">
-            <a:schemeClr val="accent1"/>
-          </a:lnRef>
-          <a:fillRef idx="0">
-            <a:schemeClr val="accent1"/>
-          </a:fillRef>
-          <a:effectRef idx="0">
-            <a:schemeClr val="accent1"/>
-          </a:effectRef>
-          <a:fontRef idx="minor">
-            <a:schemeClr val="tx1"/>
-          </a:fontRef>
-        </p:style>
-      </p:cxnSp>
-      <p:cxnSp>
-        <p:nvCxnSpPr>
-          <p:cNvPr id="34" name="Connector 33"/>
-          <p:cNvCxnSpPr/>
-          <p:nvPr/>
-        </p:nvCxnSpPr>
-        <p:spPr>
-          <a:xfrm>
-            <a:off x="11887200" y="2286000"/>
-            <a:ext cx="0" cy="2395728"/>
-          </a:xfrm>
-          <a:prstGeom prst="line">
-            <a:avLst/>
-          </a:prstGeom>
-          <a:ln w="14604">
-            <a:solidFill>
-              <a:srgbClr val="59636E"/>
-            </a:solidFill>
-          </a:ln>
-          <a:effectLst/>
-        </p:spPr>
-        <p:style>
-          <a:lnRef idx="2">
-            <a:schemeClr val="accent1"/>
-          </a:lnRef>
-          <a:fillRef idx="0">
-            <a:schemeClr val="accent1"/>
-          </a:fillRef>
-          <a:effectRef idx="0">
-            <a:schemeClr val="accent1"/>
-          </a:effectRef>
-          <a:fontRef idx="minor">
-            <a:schemeClr val="tx1"/>
-          </a:fontRef>
-        </p:style>
-      </p:cxnSp>
-      <p:cxnSp>
-        <p:nvCxnSpPr>
-          <p:cNvPr id="35" name="Connector 34"/>
-          <p:cNvCxnSpPr/>
-          <p:nvPr/>
-        </p:nvCxnSpPr>
-        <p:spPr>
-          <a:xfrm flipH="1">
-            <a:off x="8915400" y="4681728"/>
-            <a:ext cx="2971800" cy="0"/>
-          </a:xfrm>
-          <a:prstGeom prst="line">
-            <a:avLst/>
-          </a:prstGeom>
-          <a:ln w="14604">
-            <a:solidFill>
-              <a:srgbClr val="59636E"/>
-            </a:solidFill>
-            <a:tailEnd type="triangle"/>
-          </a:ln>
-          <a:effectLst/>
-        </p:spPr>
-        <p:style>
-          <a:lnRef idx="2">
-            <a:schemeClr val="accent1"/>
-          </a:lnRef>
-          <a:fillRef idx="0">
-            <a:schemeClr val="accent1"/>
-          </a:fillRef>
-          <a:effectRef idx="0">
-            <a:schemeClr val="accent1"/>
-          </a:effectRef>
-          <a:fontRef idx="minor">
-            <a:schemeClr val="tx1"/>
-          </a:fontRef>
-        </p:style>
-      </p:cxnSp>
-      <p:sp>
-        <p:nvSpPr>
-          <p:cNvPr id="36" name="Rectangle 35"/>
-          <p:cNvSpPr/>
-          <p:nvPr/>
-        </p:nvSpPr>
-        <p:spPr>
-          <a:xfrm>
-            <a:off x="11155680" y="4434840"/>
-            <a:ext cx="457200" cy="237744"/>
-          </a:xfrm>
-          <a:prstGeom prst="rect">
-            <a:avLst/>
-          </a:prstGeom>
-          <a:solidFill>
-            <a:srgbClr val="FFFFFF"/>
-          </a:solidFill>
-          <a:ln>
-            <a:noFill/>
-          </a:ln>
-          <a:effectLst/>
-        </p:spPr>
-        <p:style>
-          <a:lnRef idx="1">
-            <a:schemeClr val="accent1"/>
-          </a:lnRef>
-          <a:fillRef idx="3">
-            <a:schemeClr val="accent1"/>
-          </a:fillRef>
-          <a:effectRef idx="0">
-            <a:schemeClr val="accent1"/>
-          </a:effectRef>
-          <a:fontRef idx="minor">
-            <a:schemeClr val="lt1"/>
-          </a:fontRef>
-        </p:style>
-        <p:txBody>
-          <a:bodyPr rtlCol="0" anchor="ctr"/>
-          <a:lstStyle/>
-          <a:p>
-            <a:pPr algn="ctr"/>
-          </a:p>
-        </p:txBody>
-      </p:sp>
-      <p:sp>
-        <p:nvSpPr>
-          <p:cNvPr id="37" name="TextBox 36"/>
-          <p:cNvSpPr txBox="1"/>
-          <p:nvPr/>
-        </p:nvSpPr>
-        <p:spPr>
-          <a:xfrm>
-            <a:off x="11155680" y="4434840"/>
-            <a:ext cx="457200" cy="228600"/>
-          </a:xfrm>
-          <a:prstGeom prst="rect">
-            <a:avLst/>
-          </a:prstGeom>
-          <a:noFill/>
-        </p:spPr>
-        <p:txBody>
-          <a:bodyPr wrap="square" lIns="0" rIns="0" tIns="0" bIns="0">
-            <a:noAutofit/>
-          </a:bodyPr>
-          <a:lstStyle/>
-          <a:p>
-            <a:pPr algn="ctr">
-              <a:lnSpc>
-                <a:spcPct val="108000"/>
-              </a:lnSpc>
-              <a:spcAft>
-                <a:spcPts val="0"/>
-              </a:spcAft>
-              <a:defRPr sz="1250" b="1">
-                <a:solidFill>
-                  <a:srgbClr val="59636E"/>
-                </a:solidFill>
-                <a:latin typeface="Arial"/>
-              </a:defRPr>
-            </a:pPr>
-            <a:r>
-              <a:t>Có</a:t>
-            </a:r>
-          </a:p>
-        </p:txBody>
-      </p:sp>
-      <p:sp>
-        <p:nvSpPr>
-          <p:cNvPr id="38" name="Rectangle 37"/>
-          <p:cNvSpPr/>
-          <p:nvPr/>
-        </p:nvSpPr>
-        <p:spPr>
-          <a:xfrm>
-            <a:off x="594360" y="5486400"/>
-            <a:ext cx="3383280" cy="585216"/>
-          </a:xfrm>
-          <a:prstGeom prst="rect">
-            <a:avLst/>
-          </a:prstGeom>
-          <a:solidFill>
-            <a:srgbClr val="FFFFFF"/>
-          </a:solidFill>
-          <a:ln w="12700">
-            <a:solidFill>
-              <a:srgbClr val="284A63"/>
-            </a:solidFill>
-          </a:ln>
-          <a:effectLst/>
-        </p:spPr>
-        <p:style>
-          <a:lnRef idx="1">
-            <a:schemeClr val="accent1"/>
-          </a:lnRef>
-          <a:fillRef idx="3">
-            <a:schemeClr val="accent1"/>
-          </a:fillRef>
-          <a:effectRef idx="0">
-            <a:schemeClr val="accent1"/>
-          </a:effectRef>
-          <a:fontRef idx="minor">
-            <a:schemeClr val="lt1"/>
-          </a:fontRef>
-        </p:style>
-        <p:txBody>
-          <a:bodyPr rtlCol="0" anchor="ctr"/>
-          <a:lstStyle/>
-          <a:p>
-            <a:pPr algn="ctr"/>
-          </a:p>
-        </p:txBody>
-      </p:sp>
-      <p:sp>
-        <p:nvSpPr>
-          <p:cNvPr id="39" name="TextBox 38"/>
-          <p:cNvSpPr txBox="1"/>
-          <p:nvPr/>
-        </p:nvSpPr>
-        <p:spPr>
-          <a:xfrm>
-            <a:off x="685800" y="5532120"/>
-            <a:ext cx="3200400" cy="493776"/>
-          </a:xfrm>
-          <a:prstGeom prst="rect">
-            <a:avLst/>
-          </a:prstGeom>
-          <a:noFill/>
-        </p:spPr>
-        <p:txBody>
-          <a:bodyPr wrap="square" lIns="0" rIns="0" tIns="0" bIns="0" anchor="ctr">
-            <a:noAutofit/>
-          </a:bodyPr>
-          <a:lstStyle/>
-          <a:p>
-            <a:pPr algn="ctr">
-              <a:lnSpc>
-                <a:spcPct val="108000"/>
-              </a:lnSpc>
-              <a:spcAft>
-                <a:spcPts val="0"/>
-              </a:spcAft>
-              <a:defRPr sz="1800" b="0">
-                <a:solidFill>
-                  <a:srgbClr val="17212B"/>
-                </a:solidFill>
-                <a:latin typeface="Arial"/>
-              </a:defRPr>
-            </a:pPr>
-            <a:r>
-              <a:t>Dương: hoàn tiền</a:t>
-            </a:r>
-          </a:p>
-        </p:txBody>
-      </p:sp>
-      <p:sp>
-        <p:nvSpPr>
-          <p:cNvPr id="40" name="Rectangle 39"/>
-          <p:cNvSpPr/>
-          <p:nvPr/>
-        </p:nvSpPr>
-        <p:spPr>
-          <a:xfrm>
-            <a:off x="4389120" y="5486400"/>
-            <a:ext cx="3383280" cy="585216"/>
-          </a:xfrm>
-          <a:prstGeom prst="rect">
-            <a:avLst/>
-          </a:prstGeom>
-          <a:solidFill>
-            <a:srgbClr val="FFFFFF"/>
-          </a:solidFill>
-          <a:ln w="12700">
-            <a:solidFill>
-              <a:srgbClr val="284A63"/>
-            </a:solidFill>
-          </a:ln>
-          <a:effectLst/>
-        </p:spPr>
-        <p:style>
-          <a:lnRef idx="1">
-            <a:schemeClr val="accent1"/>
-          </a:lnRef>
-          <a:fillRef idx="3">
-            <a:schemeClr val="accent1"/>
-          </a:fillRef>
-          <a:effectRef idx="0">
-            <a:schemeClr val="accent1"/>
-          </a:effectRef>
-          <a:fontRef idx="minor">
-            <a:schemeClr val="lt1"/>
-          </a:fontRef>
-        </p:style>
-        <p:txBody>
-          <a:bodyPr rtlCol="0" anchor="ctr"/>
-          <a:lstStyle/>
-          <a:p>
-            <a:pPr algn="ctr"/>
-          </a:p>
-        </p:txBody>
-      </p:sp>
-      <p:sp>
-        <p:nvSpPr>
-          <p:cNvPr id="41" name="TextBox 40"/>
-          <p:cNvSpPr txBox="1"/>
-          <p:nvPr/>
-        </p:nvSpPr>
-        <p:spPr>
-          <a:xfrm>
-            <a:off x="4480559" y="5532120"/>
-            <a:ext cx="3200400" cy="493776"/>
-          </a:xfrm>
-          <a:prstGeom prst="rect">
-            <a:avLst/>
-          </a:prstGeom>
-          <a:noFill/>
-        </p:spPr>
-        <p:txBody>
-          <a:bodyPr wrap="square" lIns="0" rIns="0" tIns="0" bIns="0" anchor="ctr">
-            <a:noAutofit/>
-          </a:bodyPr>
-          <a:lstStyle/>
-          <a:p>
-            <a:pPr algn="ctr">
-              <a:lnSpc>
-                <a:spcPct val="108000"/>
-              </a:lnSpc>
-              <a:spcAft>
-                <a:spcPts val="0"/>
-              </a:spcAft>
-              <a:defRPr sz="1600" b="0">
-                <a:solidFill>
-                  <a:srgbClr val="17212B"/>
-                </a:solidFill>
-                <a:latin typeface="Arial"/>
-              </a:defRPr>
-            </a:pPr>
-            <a:r>
-              <a:t>Bằng 0: không hoàn / thu thêm</a:t>
-            </a:r>
-          </a:p>
-        </p:txBody>
-      </p:sp>
-      <p:sp>
-        <p:nvSpPr>
-          <p:cNvPr id="42" name="Rectangle 41"/>
-          <p:cNvSpPr/>
-          <p:nvPr/>
-        </p:nvSpPr>
-        <p:spPr>
-          <a:xfrm>
-            <a:off x="8183879" y="5486400"/>
-            <a:ext cx="3383280" cy="585216"/>
-          </a:xfrm>
-          <a:prstGeom prst="rect">
-            <a:avLst/>
-          </a:prstGeom>
-          <a:solidFill>
-            <a:srgbClr val="FFFFFF"/>
-          </a:solidFill>
-          <a:ln w="12700">
-            <a:solidFill>
-              <a:srgbClr val="284A63"/>
-            </a:solidFill>
-          </a:ln>
-          <a:effectLst/>
-        </p:spPr>
-        <p:style>
-          <a:lnRef idx="1">
-            <a:schemeClr val="accent1"/>
-          </a:lnRef>
-          <a:fillRef idx="3">
-            <a:schemeClr val="accent1"/>
-          </a:fillRef>
-          <a:effectRef idx="0">
-            <a:schemeClr val="accent1"/>
-          </a:effectRef>
-          <a:fontRef idx="minor">
-            <a:schemeClr val="lt1"/>
-          </a:fontRef>
-        </p:style>
-        <p:txBody>
-          <a:bodyPr rtlCol="0" anchor="ctr"/>
-          <a:lstStyle/>
-          <a:p>
-            <a:pPr algn="ctr"/>
-          </a:p>
-        </p:txBody>
-      </p:sp>
-      <p:sp>
-        <p:nvSpPr>
-          <p:cNvPr id="43" name="TextBox 42"/>
+          <p:cNvPr id="46" name="TextBox 45"/>
           <p:cNvSpPr txBox="1"/>
           <p:nvPr/>
         </p:nvSpPr>
@@ -27312,123 +28349,14 @@
       </p:sp>
       <p:cxnSp>
         <p:nvCxnSpPr>
-          <p:cNvPr id="44" name="Connector 43"/>
-          <p:cNvCxnSpPr/>
-          <p:nvPr/>
-        </p:nvCxnSpPr>
-        <p:spPr>
-          <a:xfrm>
-            <a:off x="7498079" y="5029200"/>
-            <a:ext cx="0" cy="201168"/>
-          </a:xfrm>
-          <a:prstGeom prst="line">
-            <a:avLst/>
-          </a:prstGeom>
-          <a:ln w="14604">
-            <a:solidFill>
-              <a:srgbClr val="59636E"/>
-            </a:solidFill>
-          </a:ln>
-          <a:effectLst/>
-        </p:spPr>
-        <p:style>
-          <a:lnRef idx="2">
-            <a:schemeClr val="accent1"/>
-          </a:lnRef>
-          <a:fillRef idx="0">
-            <a:schemeClr val="accent1"/>
-          </a:fillRef>
-          <a:effectRef idx="0">
-            <a:schemeClr val="accent1"/>
-          </a:effectRef>
-          <a:fontRef idx="minor">
-            <a:schemeClr val="tx1"/>
-          </a:fontRef>
-        </p:style>
-      </p:cxnSp>
-      <p:cxnSp>
-        <p:nvCxnSpPr>
-          <p:cNvPr id="45" name="Connector 44"/>
-          <p:cNvCxnSpPr/>
-          <p:nvPr/>
-        </p:nvCxnSpPr>
-        <p:spPr>
-          <a:xfrm flipH="1">
-            <a:off x="2286000" y="5230368"/>
-            <a:ext cx="5212079" cy="0"/>
-          </a:xfrm>
-          <a:prstGeom prst="line">
-            <a:avLst/>
-          </a:prstGeom>
-          <a:ln w="14604">
-            <a:solidFill>
-              <a:srgbClr val="59636E"/>
-            </a:solidFill>
-          </a:ln>
-          <a:effectLst/>
-        </p:spPr>
-        <p:style>
-          <a:lnRef idx="2">
-            <a:schemeClr val="accent1"/>
-          </a:lnRef>
-          <a:fillRef idx="0">
-            <a:schemeClr val="accent1"/>
-          </a:fillRef>
-          <a:effectRef idx="0">
-            <a:schemeClr val="accent1"/>
-          </a:effectRef>
-          <a:fontRef idx="minor">
-            <a:schemeClr val="tx1"/>
-          </a:fontRef>
-        </p:style>
-      </p:cxnSp>
-      <p:cxnSp>
-        <p:nvCxnSpPr>
-          <p:cNvPr id="46" name="Connector 45"/>
-          <p:cNvCxnSpPr/>
-          <p:nvPr/>
-        </p:nvCxnSpPr>
-        <p:spPr>
-          <a:xfrm>
-            <a:off x="2286000" y="5230368"/>
-            <a:ext cx="0" cy="256032"/>
-          </a:xfrm>
-          <a:prstGeom prst="line">
-            <a:avLst/>
-          </a:prstGeom>
-          <a:ln w="14604">
-            <a:solidFill>
-              <a:srgbClr val="59636E"/>
-            </a:solidFill>
-            <a:tailEnd type="triangle"/>
-          </a:ln>
-          <a:effectLst/>
-        </p:spPr>
-        <p:style>
-          <a:lnRef idx="2">
-            <a:schemeClr val="accent1"/>
-          </a:lnRef>
-          <a:fillRef idx="0">
-            <a:schemeClr val="accent1"/>
-          </a:fillRef>
-          <a:effectRef idx="0">
-            <a:schemeClr val="accent1"/>
-          </a:effectRef>
-          <a:fontRef idx="minor">
-            <a:schemeClr val="tx1"/>
-          </a:fontRef>
-        </p:style>
-      </p:cxnSp>
-      <p:cxnSp>
-        <p:nvCxnSpPr>
           <p:cNvPr id="47" name="Connector 46"/>
           <p:cNvCxnSpPr/>
           <p:nvPr/>
         </p:nvCxnSpPr>
         <p:spPr>
-          <a:xfrm flipH="1">
-            <a:off x="6080760" y="5230368"/>
-            <a:ext cx="1417319" cy="0"/>
+          <a:xfrm>
+            <a:off x="7498079" y="5276088"/>
+            <a:ext cx="0" cy="109728"/>
           </a:xfrm>
           <a:prstGeom prst="line">
             <a:avLst/>
@@ -27462,9 +28390,9 @@
           <p:nvPr/>
         </p:nvCxnSpPr>
         <p:spPr>
-          <a:xfrm>
-            <a:off x="6080760" y="5230368"/>
-            <a:ext cx="0" cy="256032"/>
+          <a:xfrm flipH="1">
+            <a:off x="2286000" y="5385816"/>
+            <a:ext cx="5212079" cy="0"/>
           </a:xfrm>
           <a:prstGeom prst="line">
             <a:avLst/>
@@ -27473,7 +28401,6 @@
             <a:solidFill>
               <a:srgbClr val="59636E"/>
             </a:solidFill>
-            <a:tailEnd type="triangle"/>
           </a:ln>
           <a:effectLst/>
         </p:spPr>
@@ -27500,8 +28427,8 @@
         </p:nvCxnSpPr>
         <p:spPr>
           <a:xfrm>
-            <a:off x="7498079" y="5230368"/>
-            <a:ext cx="2377441" cy="0"/>
+            <a:off x="2286000" y="5385816"/>
+            <a:ext cx="0" cy="100584"/>
           </a:xfrm>
           <a:prstGeom prst="line">
             <a:avLst/>
@@ -27510,6 +28437,7 @@
             <a:solidFill>
               <a:srgbClr val="59636E"/>
             </a:solidFill>
+            <a:tailEnd type="triangle"/>
           </a:ln>
           <a:effectLst/>
         </p:spPr>
@@ -27535,9 +28463,45 @@
           <p:nvPr/>
         </p:nvCxnSpPr>
         <p:spPr>
-          <a:xfrm>
-            <a:off x="9875520" y="5230368"/>
-            <a:ext cx="0" cy="256032"/>
+          <a:xfrm flipH="1">
+            <a:off x="6080760" y="5385816"/>
+            <a:ext cx="1417319" cy="0"/>
+          </a:xfrm>
+          <a:prstGeom prst="line">
+            <a:avLst/>
+          </a:prstGeom>
+          <a:ln w="14604">
+            <a:solidFill>
+              <a:srgbClr val="59636E"/>
+            </a:solidFill>
+          </a:ln>
+          <a:effectLst/>
+        </p:spPr>
+        <p:style>
+          <a:lnRef idx="2">
+            <a:schemeClr val="accent1"/>
+          </a:lnRef>
+          <a:fillRef idx="0">
+            <a:schemeClr val="accent1"/>
+          </a:fillRef>
+          <a:effectRef idx="0">
+            <a:schemeClr val="accent1"/>
+          </a:effectRef>
+          <a:fontRef idx="minor">
+            <a:schemeClr val="tx1"/>
+          </a:fontRef>
+        </p:style>
+      </p:cxnSp>
+      <p:cxnSp>
+        <p:nvCxnSpPr>
+          <p:cNvPr id="51" name="Connector 50"/>
+          <p:cNvCxnSpPr/>
+          <p:nvPr/>
+        </p:nvCxnSpPr>
+        <p:spPr>
+          <a:xfrm>
+            <a:off x="6080760" y="5385816"/>
+            <a:ext cx="0" cy="100584"/>
           </a:xfrm>
           <a:prstGeom prst="line">
             <a:avLst/>
@@ -27565,9 +28529,82 @@
           </a:fontRef>
         </p:style>
       </p:cxnSp>
-      <p:sp>
-        <p:nvSpPr>
-          <p:cNvPr id="51" name="TextBox 50"/>
+      <p:cxnSp>
+        <p:nvCxnSpPr>
+          <p:cNvPr id="52" name="Connector 51"/>
+          <p:cNvCxnSpPr/>
+          <p:nvPr/>
+        </p:nvCxnSpPr>
+        <p:spPr>
+          <a:xfrm>
+            <a:off x="7498079" y="5385816"/>
+            <a:ext cx="2377441" cy="0"/>
+          </a:xfrm>
+          <a:prstGeom prst="line">
+            <a:avLst/>
+          </a:prstGeom>
+          <a:ln w="14604">
+            <a:solidFill>
+              <a:srgbClr val="59636E"/>
+            </a:solidFill>
+          </a:ln>
+          <a:effectLst/>
+        </p:spPr>
+        <p:style>
+          <a:lnRef idx="2">
+            <a:schemeClr val="accent1"/>
+          </a:lnRef>
+          <a:fillRef idx="0">
+            <a:schemeClr val="accent1"/>
+          </a:fillRef>
+          <a:effectRef idx="0">
+            <a:schemeClr val="accent1"/>
+          </a:effectRef>
+          <a:fontRef idx="minor">
+            <a:schemeClr val="tx1"/>
+          </a:fontRef>
+        </p:style>
+      </p:cxnSp>
+      <p:cxnSp>
+        <p:nvCxnSpPr>
+          <p:cNvPr id="53" name="Connector 52"/>
+          <p:cNvCxnSpPr/>
+          <p:nvPr/>
+        </p:nvCxnSpPr>
+        <p:spPr>
+          <a:xfrm>
+            <a:off x="9875520" y="5385816"/>
+            <a:ext cx="0" cy="100584"/>
+          </a:xfrm>
+          <a:prstGeom prst="line">
+            <a:avLst/>
+          </a:prstGeom>
+          <a:ln w="14604">
+            <a:solidFill>
+              <a:srgbClr val="59636E"/>
+            </a:solidFill>
+            <a:tailEnd type="triangle"/>
+          </a:ln>
+          <a:effectLst/>
+        </p:spPr>
+        <p:style>
+          <a:lnRef idx="2">
+            <a:schemeClr val="accent1"/>
+          </a:lnRef>
+          <a:fillRef idx="0">
+            <a:schemeClr val="accent1"/>
+          </a:fillRef>
+          <a:effectRef idx="0">
+            <a:schemeClr val="accent1"/>
+          </a:effectRef>
+          <a:fontRef idx="minor">
+            <a:schemeClr val="tx1"/>
+          </a:fontRef>
+        </p:style>
+      </p:cxnSp>
+      <p:sp>
+        <p:nvSpPr>
+          <p:cNvPr id="54" name="TextBox 53"/>
           <p:cNvSpPr txBox="1"/>
           <p:nvPr/>
         </p:nvSpPr>
@@ -27602,7 +28639,7 @@
               </a:defRPr>
             </a:pPr>
             <a:r>
-              <a:t>Cấn cọc không phải tiền thu mới. Phần nợ chưa được thanh toán vẫn được giữ lại.</a:t>
+              <a:t>Còn PENDING thì dừng. Cấn cọc không phải tiền thu mới; phần nợ chưa trả vẫn được giữ lại.</a:t>
             </a:r>
           </a:p>
         </p:txBody>
@@ -28809,48 +29846,6 @@
           </a:graphicData>
         </a:graphic>
       </p:graphicFrame>
-      <p:sp>
-        <p:nvSpPr>
-          <p:cNvPr id="9" name="TextBox 8"/>
-          <p:cNvSpPr txBox="1"/>
-          <p:nvPr/>
-        </p:nvSpPr>
-        <p:spPr>
-          <a:xfrm>
-            <a:off x="731520" y="5989320"/>
-            <a:ext cx="10789920" cy="320040"/>
-          </a:xfrm>
-          <a:prstGeom prst="rect">
-            <a:avLst/>
-          </a:prstGeom>
-          <a:noFill/>
-        </p:spPr>
-        <p:txBody>
-          <a:bodyPr wrap="square" lIns="0" rIns="0" tIns="0" bIns="0">
-            <a:noAutofit/>
-          </a:bodyPr>
-          <a:lstStyle/>
-          <a:p>
-            <a:pPr algn="l">
-              <a:lnSpc>
-                <a:spcPct val="108000"/>
-              </a:lnSpc>
-              <a:spcAft>
-                <a:spcPts val="0"/>
-              </a:spcAft>
-              <a:defRPr sz="1700" b="1">
-                <a:solidFill>
-                  <a:srgbClr val="284A63"/>
-                </a:solidFill>
-                <a:latin typeface="Arial"/>
-              </a:defRPr>
-            </a:pPr>
-            <a:r>
-              <a:t>138 cột • 17 PK • 28 FK • 55 CHECK • 2 EXCLUDE • 6 view tính toán</a:t>
-            </a:r>
-          </a:p>
-        </p:txBody>
-      </p:sp>
     </p:spTree>
   </p:cSld>
   <p:clrMapOvr>

</xml_diff>